<commit_message>
fix pitch deck layout spacing to prevent title, subtitle, and content overlap
</commit_message>
<xml_diff>
--- a/documentation/version-1/slides/ecobrief-green-tech-pitch.pptx
+++ b/documentation/version-1/slides/ecobrief-green-tech-pitch.pptx
@@ -693,21 +693,21 @@
         </p:nvSpPr>
         <p:spPr>
           <a:xfrm>
-            <a:off x="620000" y="775000"/>
-            <a:ext cx="7700000" cy="980000"/>
-          </a:xfrm>
-          <a:prstGeom prst="rect">
-            <a:avLst/>
-          </a:prstGeom>
-          <a:noFill/>
-        </p:spPr>
-        <p:txBody>
-          <a:bodyPr wrap="square" anchor="t"/>
-          <a:lstStyle/>
-          <a:p>
-            <a:pPr algn="l"/>
-            <a:r>
-              <a:rPr lang="es-BO" sz="4050" dirty="0">
+            <a:off x="620000" y="760000"/>
+            <a:ext cx="8250000" cy="1260000"/>
+          </a:xfrm>
+          <a:prstGeom prst="rect">
+            <a:avLst/>
+          </a:prstGeom>
+          <a:noFill/>
+        </p:spPr>
+        <p:txBody>
+          <a:bodyPr wrap="square" anchor="t"/>
+          <a:lstStyle/>
+          <a:p>
+            <a:pPr algn="l"/>
+            <a:r>
+              <a:rPr lang="es-BO" sz="3450" dirty="0">
                 <a:b/>
                 <a:solidFill>
                   <a:srgbClr val="12372A"/>
@@ -727,21 +727,21 @@
         </p:nvSpPr>
         <p:spPr>
           <a:xfrm>
-            <a:off x="630000" y="1710000"/>
-            <a:ext cx="7850000" cy="570000"/>
-          </a:xfrm>
-          <a:prstGeom prst="rect">
-            <a:avLst/>
-          </a:prstGeom>
-          <a:noFill/>
-        </p:spPr>
-        <p:txBody>
-          <a:bodyPr wrap="square" anchor="t"/>
-          <a:lstStyle/>
-          <a:p>
-            <a:pPr algn="l"/>
-            <a:r>
-              <a:rPr lang="es-BO" sz="1950" dirty="0">
+            <a:off x="630000" y="2140000"/>
+            <a:ext cx="8350000" cy="620000"/>
+          </a:xfrm>
+          <a:prstGeom prst="rect">
+            <a:avLst/>
+          </a:prstGeom>
+          <a:noFill/>
+        </p:spPr>
+        <p:txBody>
+          <a:bodyPr wrap="square" anchor="t"/>
+          <a:lstStyle/>
+          <a:p>
+            <a:pPr algn="l"/>
+            <a:r>
+              <a:rPr lang="es-BO" sz="1850" dirty="0">
                 <a:solidFill>
                   <a:srgbClr val="56635C"/>
                 </a:solidFill>
@@ -760,8 +760,8 @@
         </p:nvSpPr>
         <p:spPr>
           <a:xfrm>
-            <a:off x="820000" y="2680000"/>
-            <a:ext cx="3780000" cy="3520000"/>
+            <a:off x="820000" y="3030000"/>
+            <a:ext cx="3780000" cy="3220000"/>
           </a:xfrm>
           <a:prstGeom prst="roundRect">
             <a:avLst/>
@@ -789,21 +789,21 @@
         </p:nvSpPr>
         <p:spPr>
           <a:xfrm>
-            <a:off x="1080000" y="2930000"/>
-            <a:ext cx="3260000" cy="360000"/>
-          </a:xfrm>
-          <a:prstGeom prst="rect">
-            <a:avLst/>
-          </a:prstGeom>
-          <a:noFill/>
-        </p:spPr>
-        <p:txBody>
-          <a:bodyPr wrap="square" anchor="t"/>
-          <a:lstStyle/>
-          <a:p>
-            <a:pPr algn="l"/>
-            <a:r>
-              <a:rPr lang="es-BO" sz="2300" dirty="0">
+            <a:off x="1080000" y="3260000"/>
+            <a:ext cx="3260000" cy="340000"/>
+          </a:xfrm>
+          <a:prstGeom prst="rect">
+            <a:avLst/>
+          </a:prstGeom>
+          <a:noFill/>
+        </p:spPr>
+        <p:txBody>
+          <a:bodyPr wrap="square" anchor="t"/>
+          <a:lstStyle/>
+          <a:p>
+            <a:pPr algn="l"/>
+            <a:r>
+              <a:rPr lang="es-BO" sz="2200" dirty="0">
                 <a:b/>
                 <a:solidFill>
                   <a:srgbClr val="1B7F5C"/>
@@ -823,7 +823,7 @@
         </p:nvSpPr>
         <p:spPr>
           <a:xfrm>
-            <a:off x="1120000" y="3512000"/>
+            <a:off x="1120000" y="3802000"/>
             <a:ext cx="95000" cy="95000"/>
           </a:xfrm>
           <a:prstGeom prst="ellipse">
@@ -850,7 +850,7 @@
         </p:nvSpPr>
         <p:spPr>
           <a:xfrm>
-            <a:off x="1275000" y="3460000"/>
+            <a:off x="1275000" y="3750000"/>
             <a:ext cx="3045000" cy="260000"/>
           </a:xfrm>
           <a:prstGeom prst="rect">
@@ -883,7 +883,7 @@
         </p:nvSpPr>
         <p:spPr>
           <a:xfrm>
-            <a:off x="1120000" y="3897000"/>
+            <a:off x="1120000" y="4187000"/>
             <a:ext cx="95000" cy="95000"/>
           </a:xfrm>
           <a:prstGeom prst="ellipse">
@@ -910,7 +910,7 @@
         </p:nvSpPr>
         <p:spPr>
           <a:xfrm>
-            <a:off x="1275000" y="3845000"/>
+            <a:off x="1275000" y="4135000"/>
             <a:ext cx="3045000" cy="260000"/>
           </a:xfrm>
           <a:prstGeom prst="rect">
@@ -943,7 +943,7 @@
         </p:nvSpPr>
         <p:spPr>
           <a:xfrm>
-            <a:off x="1120000" y="4282000"/>
+            <a:off x="1120000" y="4572000"/>
             <a:ext cx="95000" cy="95000"/>
           </a:xfrm>
           <a:prstGeom prst="ellipse">
@@ -970,7 +970,7 @@
         </p:nvSpPr>
         <p:spPr>
           <a:xfrm>
-            <a:off x="1275000" y="4230000"/>
+            <a:off x="1275000" y="4520000"/>
             <a:ext cx="3045000" cy="260000"/>
           </a:xfrm>
           <a:prstGeom prst="rect">
@@ -1003,7 +1003,7 @@
         </p:nvSpPr>
         <p:spPr>
           <a:xfrm>
-            <a:off x="1120000" y="4667000"/>
+            <a:off x="1120000" y="4957000"/>
             <a:ext cx="95000" cy="95000"/>
           </a:xfrm>
           <a:prstGeom prst="ellipse">
@@ -1030,7 +1030,7 @@
         </p:nvSpPr>
         <p:spPr>
           <a:xfrm>
-            <a:off x="1275000" y="4615000"/>
+            <a:off x="1275000" y="4905000"/>
             <a:ext cx="3045000" cy="260000"/>
           </a:xfrm>
           <a:prstGeom prst="rect">
@@ -1063,8 +1063,8 @@
         </p:nvSpPr>
         <p:spPr>
           <a:xfrm>
-            <a:off x="4940000" y="2680000"/>
-            <a:ext cx="3780000" cy="3520000"/>
+            <a:off x="4940000" y="3030000"/>
+            <a:ext cx="3780000" cy="3220000"/>
           </a:xfrm>
           <a:prstGeom prst="roundRect">
             <a:avLst/>
@@ -1092,21 +1092,21 @@
         </p:nvSpPr>
         <p:spPr>
           <a:xfrm>
-            <a:off x="5200000" y="2930000"/>
-            <a:ext cx="3260000" cy="360000"/>
-          </a:xfrm>
-          <a:prstGeom prst="rect">
-            <a:avLst/>
-          </a:prstGeom>
-          <a:noFill/>
-        </p:spPr>
-        <p:txBody>
-          <a:bodyPr wrap="square" anchor="t"/>
-          <a:lstStyle/>
-          <a:p>
-            <a:pPr algn="l"/>
-            <a:r>
-              <a:rPr lang="es-BO" sz="2300" dirty="0">
+            <a:off x="5200000" y="3260000"/>
+            <a:ext cx="3260000" cy="340000"/>
+          </a:xfrm>
+          <a:prstGeom prst="rect">
+            <a:avLst/>
+          </a:prstGeom>
+          <a:noFill/>
+        </p:spPr>
+        <p:txBody>
+          <a:bodyPr wrap="square" anchor="t"/>
+          <a:lstStyle/>
+          <a:p>
+            <a:pPr algn="l"/>
+            <a:r>
+              <a:rPr lang="es-BO" sz="2200" dirty="0">
                 <a:b/>
                 <a:solidFill>
                   <a:srgbClr val="1B7F5C"/>
@@ -1126,7 +1126,7 @@
         </p:nvSpPr>
         <p:spPr>
           <a:xfrm>
-            <a:off x="5240000" y="3512000"/>
+            <a:off x="5240000" y="3802000"/>
             <a:ext cx="95000" cy="95000"/>
           </a:xfrm>
           <a:prstGeom prst="ellipse">
@@ -1153,7 +1153,7 @@
         </p:nvSpPr>
         <p:spPr>
           <a:xfrm>
-            <a:off x="5395000" y="3460000"/>
+            <a:off x="5395000" y="3750000"/>
             <a:ext cx="3045000" cy="260000"/>
           </a:xfrm>
           <a:prstGeom prst="rect">
@@ -1186,7 +1186,7 @@
         </p:nvSpPr>
         <p:spPr>
           <a:xfrm>
-            <a:off x="5240000" y="3897000"/>
+            <a:off x="5240000" y="4187000"/>
             <a:ext cx="95000" cy="95000"/>
           </a:xfrm>
           <a:prstGeom prst="ellipse">
@@ -1213,7 +1213,7 @@
         </p:nvSpPr>
         <p:spPr>
           <a:xfrm>
-            <a:off x="5395000" y="3845000"/>
+            <a:off x="5395000" y="4135000"/>
             <a:ext cx="3045000" cy="260000"/>
           </a:xfrm>
           <a:prstGeom prst="rect">
@@ -1246,7 +1246,7 @@
         </p:nvSpPr>
         <p:spPr>
           <a:xfrm>
-            <a:off x="5240000" y="4282000"/>
+            <a:off x="5240000" y="4572000"/>
             <a:ext cx="95000" cy="95000"/>
           </a:xfrm>
           <a:prstGeom prst="ellipse">
@@ -1273,7 +1273,7 @@
         </p:nvSpPr>
         <p:spPr>
           <a:xfrm>
-            <a:off x="5395000" y="4230000"/>
+            <a:off x="5395000" y="4520000"/>
             <a:ext cx="3045000" cy="260000"/>
           </a:xfrm>
           <a:prstGeom prst="rect">
@@ -1306,8 +1306,8 @@
         </p:nvSpPr>
         <p:spPr>
           <a:xfrm>
-            <a:off x="9060000" y="2680000"/>
-            <a:ext cx="3780000" cy="3520000"/>
+            <a:off x="9060000" y="3030000"/>
+            <a:ext cx="3780000" cy="3220000"/>
           </a:xfrm>
           <a:prstGeom prst="roundRect">
             <a:avLst/>
@@ -1335,21 +1335,21 @@
         </p:nvSpPr>
         <p:spPr>
           <a:xfrm>
-            <a:off x="9320000" y="2930000"/>
-            <a:ext cx="3260000" cy="360000"/>
-          </a:xfrm>
-          <a:prstGeom prst="rect">
-            <a:avLst/>
-          </a:prstGeom>
-          <a:noFill/>
-        </p:spPr>
-        <p:txBody>
-          <a:bodyPr wrap="square" anchor="t"/>
-          <a:lstStyle/>
-          <a:p>
-            <a:pPr algn="l"/>
-            <a:r>
-              <a:rPr lang="es-BO" sz="2300" dirty="0">
+            <a:off x="9320000" y="3260000"/>
+            <a:ext cx="3260000" cy="340000"/>
+          </a:xfrm>
+          <a:prstGeom prst="rect">
+            <a:avLst/>
+          </a:prstGeom>
+          <a:noFill/>
+        </p:spPr>
+        <p:txBody>
+          <a:bodyPr wrap="square" anchor="t"/>
+          <a:lstStyle/>
+          <a:p>
+            <a:pPr algn="l"/>
+            <a:r>
+              <a:rPr lang="es-BO" sz="2200" dirty="0">
                 <a:b/>
                 <a:solidFill>
                   <a:srgbClr val="1B7F5C"/>
@@ -1369,7 +1369,7 @@
         </p:nvSpPr>
         <p:spPr>
           <a:xfrm>
-            <a:off x="9360000" y="3512000"/>
+            <a:off x="9360000" y="3802000"/>
             <a:ext cx="95000" cy="95000"/>
           </a:xfrm>
           <a:prstGeom prst="ellipse">
@@ -1396,7 +1396,7 @@
         </p:nvSpPr>
         <p:spPr>
           <a:xfrm>
-            <a:off x="9515000" y="3460000"/>
+            <a:off x="9515000" y="3750000"/>
             <a:ext cx="3045000" cy="260000"/>
           </a:xfrm>
           <a:prstGeom prst="rect">
@@ -1429,7 +1429,7 @@
         </p:nvSpPr>
         <p:spPr>
           <a:xfrm>
-            <a:off x="9360000" y="3897000"/>
+            <a:off x="9360000" y="4187000"/>
             <a:ext cx="95000" cy="95000"/>
           </a:xfrm>
           <a:prstGeom prst="ellipse">
@@ -1456,7 +1456,7 @@
         </p:nvSpPr>
         <p:spPr>
           <a:xfrm>
-            <a:off x="9515000" y="3845000"/>
+            <a:off x="9515000" y="4135000"/>
             <a:ext cx="3045000" cy="260000"/>
           </a:xfrm>
           <a:prstGeom prst="rect">
@@ -1489,7 +1489,7 @@
         </p:nvSpPr>
         <p:spPr>
           <a:xfrm>
-            <a:off x="9360000" y="4282000"/>
+            <a:off x="9360000" y="4572000"/>
             <a:ext cx="95000" cy="95000"/>
           </a:xfrm>
           <a:prstGeom prst="ellipse">
@@ -1516,7 +1516,7 @@
         </p:nvSpPr>
         <p:spPr>
           <a:xfrm>
-            <a:off x="9515000" y="4230000"/>
+            <a:off x="9515000" y="4520000"/>
             <a:ext cx="3045000" cy="260000"/>
           </a:xfrm>
           <a:prstGeom prst="rect">
@@ -1696,21 +1696,21 @@
         </p:nvSpPr>
         <p:spPr>
           <a:xfrm>
-            <a:off x="620000" y="775000"/>
-            <a:ext cx="7700000" cy="980000"/>
-          </a:xfrm>
-          <a:prstGeom prst="rect">
-            <a:avLst/>
-          </a:prstGeom>
-          <a:noFill/>
-        </p:spPr>
-        <p:txBody>
-          <a:bodyPr wrap="square" anchor="t"/>
-          <a:lstStyle/>
-          <a:p>
-            <a:pPr algn="l"/>
-            <a:r>
-              <a:rPr lang="es-BO" sz="4050" dirty="0">
+            <a:off x="620000" y="760000"/>
+            <a:ext cx="8250000" cy="1260000"/>
+          </a:xfrm>
+          <a:prstGeom prst="rect">
+            <a:avLst/>
+          </a:prstGeom>
+          <a:noFill/>
+        </p:spPr>
+        <p:txBody>
+          <a:bodyPr wrap="square" anchor="t"/>
+          <a:lstStyle/>
+          <a:p>
+            <a:pPr algn="l"/>
+            <a:r>
+              <a:rPr lang="es-BO" sz="3450" dirty="0">
                 <a:b/>
                 <a:solidFill>
                   <a:srgbClr val="12372A"/>
@@ -1730,381 +1730,381 @@
         </p:nvSpPr>
         <p:spPr>
           <a:xfrm>
-            <a:off x="630000" y="1710000"/>
-            <a:ext cx="7850000" cy="570000"/>
-          </a:xfrm>
-          <a:prstGeom prst="rect">
-            <a:avLst/>
-          </a:prstGeom>
-          <a:noFill/>
-        </p:spPr>
-        <p:txBody>
-          <a:bodyPr wrap="square" anchor="t"/>
-          <a:lstStyle/>
-          <a:p>
-            <a:pPr algn="l"/>
+            <a:off x="630000" y="2140000"/>
+            <a:ext cx="8350000" cy="620000"/>
+          </a:xfrm>
+          <a:prstGeom prst="rect">
+            <a:avLst/>
+          </a:prstGeom>
+          <a:noFill/>
+        </p:spPr>
+        <p:txBody>
+          <a:bodyPr wrap="square" anchor="t"/>
+          <a:lstStyle/>
+          <a:p>
+            <a:pPr algn="l"/>
+            <a:r>
+              <a:rPr lang="es-BO" sz="1850" dirty="0">
+                <a:solidFill>
+                  <a:srgbClr val="56635C"/>
+                </a:solidFill>
+                <a:latin typeface="Aptos"/>
+              </a:rPr>
+              <a:t>EcoBrief convierte informacion dispersa en briefs esenciales, medibles y de bajo costo.</a:t>
+            </a:r>
+          </a:p>
+        </p:txBody>
+      </p:sp>
+      <p:sp>
+        <p:nvSpPr>
+          <p:cNvPr id="16" name="Shape"/>
+          <p:cNvSpPr/>
+          <p:nvPr/>
+        </p:nvSpPr>
+        <p:spPr>
+          <a:xfrm>
+            <a:off x="770000" y="3082000"/>
+            <a:ext cx="95000" cy="95000"/>
+          </a:xfrm>
+          <a:prstGeom prst="ellipse">
+            <a:avLst/>
+          </a:prstGeom>
+          <a:solidFill>
+            <a:srgbClr val="1B7F5C"/>
+          </a:solidFill>
+          <a:ln>
+            <a:noFill/>
+          </a:ln>
+        </p:spPr>
+        <p:txBody>
+          <a:bodyPr/>
+          <a:lstStyle/>
+          <a:p/>
+        </p:txBody>
+      </p:sp>
+      <p:sp>
+        <p:nvSpPr>
+          <p:cNvPr id="17" name="Text"/>
+          <p:cNvSpPr txBox="1"/>
+          <p:nvPr/>
+        </p:nvSpPr>
+        <p:spPr>
+          <a:xfrm>
+            <a:off x="925000" y="3030000"/>
+            <a:ext cx="6695000" cy="260000"/>
+          </a:xfrm>
+          <a:prstGeom prst="rect">
+            <a:avLst/>
+          </a:prstGeom>
+          <a:noFill/>
+        </p:spPr>
+        <p:txBody>
+          <a:bodyPr wrap="square" anchor="t"/>
+          <a:lstStyle/>
+          <a:p>
+            <a:pPr algn="l"/>
+            <a:r>
+              <a:rPr lang="es-BO" sz="2150" dirty="0">
+                <a:solidFill>
+                  <a:srgbClr val="17211B"/>
+                </a:solidFill>
+                <a:latin typeface="Aptos"/>
+              </a:rPr>
+              <a:t>Resuelve un problema cotidiano.</a:t>
+            </a:r>
+          </a:p>
+        </p:txBody>
+      </p:sp>
+      <p:sp>
+        <p:nvSpPr>
+          <p:cNvPr id="18" name="Shape"/>
+          <p:cNvSpPr/>
+          <p:nvPr/>
+        </p:nvSpPr>
+        <p:spPr>
+          <a:xfrm>
+            <a:off x="770000" y="3467000"/>
+            <a:ext cx="95000" cy="95000"/>
+          </a:xfrm>
+          <a:prstGeom prst="ellipse">
+            <a:avLst/>
+          </a:prstGeom>
+          <a:solidFill>
+            <a:srgbClr val="1B7F5C"/>
+          </a:solidFill>
+          <a:ln>
+            <a:noFill/>
+          </a:ln>
+        </p:spPr>
+        <p:txBody>
+          <a:bodyPr/>
+          <a:lstStyle/>
+          <a:p/>
+        </p:txBody>
+      </p:sp>
+      <p:sp>
+        <p:nvSpPr>
+          <p:cNvPr id="19" name="Text"/>
+          <p:cNvSpPr txBox="1"/>
+          <p:nvPr/>
+        </p:nvSpPr>
+        <p:spPr>
+          <a:xfrm>
+            <a:off x="925000" y="3415000"/>
+            <a:ext cx="6695000" cy="260000"/>
+          </a:xfrm>
+          <a:prstGeom prst="rect">
+            <a:avLst/>
+          </a:prstGeom>
+          <a:noFill/>
+        </p:spPr>
+        <p:txBody>
+          <a:bodyPr wrap="square" anchor="t"/>
+          <a:lstStyle/>
+          <a:p>
+            <a:pPr algn="l"/>
+            <a:r>
+              <a:rPr lang="es-BO" sz="2150" dirty="0">
+                <a:solidFill>
+                  <a:srgbClr val="17211B"/>
+                </a:solidFill>
+                <a:latin typeface="Aptos"/>
+              </a:rPr>
+              <a:t>Encaja directamente con Green Tech.</a:t>
+            </a:r>
+          </a:p>
+        </p:txBody>
+      </p:sp>
+      <p:sp>
+        <p:nvSpPr>
+          <p:cNvPr id="20" name="Shape"/>
+          <p:cNvSpPr/>
+          <p:nvPr/>
+        </p:nvSpPr>
+        <p:spPr>
+          <a:xfrm>
+            <a:off x="770000" y="3852000"/>
+            <a:ext cx="95000" cy="95000"/>
+          </a:xfrm>
+          <a:prstGeom prst="ellipse">
+            <a:avLst/>
+          </a:prstGeom>
+          <a:solidFill>
+            <a:srgbClr val="1B7F5C"/>
+          </a:solidFill>
+          <a:ln>
+            <a:noFill/>
+          </a:ln>
+        </p:spPr>
+        <p:txBody>
+          <a:bodyPr/>
+          <a:lstStyle/>
+          <a:p/>
+        </p:txBody>
+      </p:sp>
+      <p:sp>
+        <p:nvSpPr>
+          <p:cNvPr id="21" name="Text"/>
+          <p:cNvSpPr txBox="1"/>
+          <p:nvPr/>
+        </p:nvSpPr>
+        <p:spPr>
+          <a:xfrm>
+            <a:off x="925000" y="3800000"/>
+            <a:ext cx="6695000" cy="260000"/>
+          </a:xfrm>
+          <a:prstGeom prst="rect">
+            <a:avLst/>
+          </a:prstGeom>
+          <a:noFill/>
+        </p:spPr>
+        <p:txBody>
+          <a:bodyPr wrap="square" anchor="t"/>
+          <a:lstStyle/>
+          <a:p>
+            <a:pPr algn="l"/>
+            <a:r>
+              <a:rPr lang="es-BO" sz="2150" dirty="0">
+                <a:solidFill>
+                  <a:srgbClr val="17211B"/>
+                </a:solidFill>
+                <a:latin typeface="Aptos"/>
+              </a:rPr>
+              <a:t>Tiene MVP funcional.</a:t>
+            </a:r>
+          </a:p>
+        </p:txBody>
+      </p:sp>
+      <p:sp>
+        <p:nvSpPr>
+          <p:cNvPr id="22" name="Shape"/>
+          <p:cNvSpPr/>
+          <p:nvPr/>
+        </p:nvSpPr>
+        <p:spPr>
+          <a:xfrm>
+            <a:off x="770000" y="4237000"/>
+            <a:ext cx="95000" cy="95000"/>
+          </a:xfrm>
+          <a:prstGeom prst="ellipse">
+            <a:avLst/>
+          </a:prstGeom>
+          <a:solidFill>
+            <a:srgbClr val="1B7F5C"/>
+          </a:solidFill>
+          <a:ln>
+            <a:noFill/>
+          </a:ln>
+        </p:spPr>
+        <p:txBody>
+          <a:bodyPr/>
+          <a:lstStyle/>
+          <a:p/>
+        </p:txBody>
+      </p:sp>
+      <p:sp>
+        <p:nvSpPr>
+          <p:cNvPr id="23" name="Text"/>
+          <p:cNvSpPr txBox="1"/>
+          <p:nvPr/>
+        </p:nvSpPr>
+        <p:spPr>
+          <a:xfrm>
+            <a:off x="925000" y="4185000"/>
+            <a:ext cx="6695000" cy="260000"/>
+          </a:xfrm>
+          <a:prstGeom prst="rect">
+            <a:avLst/>
+          </a:prstGeom>
+          <a:noFill/>
+        </p:spPr>
+        <p:txBody>
+          <a:bodyPr wrap="square" anchor="t"/>
+          <a:lstStyle/>
+          <a:p>
+            <a:pPr algn="l"/>
+            <a:r>
+              <a:rPr lang="es-BO" sz="2150" dirty="0">
+                <a:solidFill>
+                  <a:srgbClr val="17211B"/>
+                </a:solidFill>
+                <a:latin typeface="Aptos"/>
+              </a:rPr>
+              <a:t>Puede escalar con costos controlados.</a:t>
+            </a:r>
+          </a:p>
+        </p:txBody>
+      </p:sp>
+      <p:sp>
+        <p:nvSpPr>
+          <p:cNvPr id="24" name="Shape"/>
+          <p:cNvSpPr/>
+          <p:nvPr/>
+        </p:nvSpPr>
+        <p:spPr>
+          <a:xfrm>
+            <a:off x="770000" y="4622000"/>
+            <a:ext cx="95000" cy="95000"/>
+          </a:xfrm>
+          <a:prstGeom prst="ellipse">
+            <a:avLst/>
+          </a:prstGeom>
+          <a:solidFill>
+            <a:srgbClr val="1B7F5C"/>
+          </a:solidFill>
+          <a:ln>
+            <a:noFill/>
+          </a:ln>
+        </p:spPr>
+        <p:txBody>
+          <a:bodyPr/>
+          <a:lstStyle/>
+          <a:p/>
+        </p:txBody>
+      </p:sp>
+      <p:sp>
+        <p:nvSpPr>
+          <p:cNvPr id="25" name="Text"/>
+          <p:cNvSpPr txBox="1"/>
+          <p:nvPr/>
+        </p:nvSpPr>
+        <p:spPr>
+          <a:xfrm>
+            <a:off x="925000" y="4570000"/>
+            <a:ext cx="6695000" cy="260000"/>
+          </a:xfrm>
+          <a:prstGeom prst="rect">
+            <a:avLst/>
+          </a:prstGeom>
+          <a:noFill/>
+        </p:spPr>
+        <p:txBody>
+          <a:bodyPr wrap="square" anchor="t"/>
+          <a:lstStyle/>
+          <a:p>
+            <a:pPr algn="l"/>
+            <a:r>
+              <a:rPr lang="es-BO" sz="2150" dirty="0">
+                <a:solidFill>
+                  <a:srgbClr val="17211B"/>
+                </a:solidFill>
+                <a:latin typeface="Aptos"/>
+              </a:rPr>
+              <a:t>Convierte impacto digital en metricas visibles.</a:t>
+            </a:r>
+          </a:p>
+        </p:txBody>
+      </p:sp>
+      <p:sp>
+        <p:nvSpPr>
+          <p:cNvPr id="26" name="Shape"/>
+          <p:cNvSpPr/>
+          <p:nvPr/>
+        </p:nvSpPr>
+        <p:spPr>
+          <a:xfrm>
+            <a:off x="8500000" y="5140000"/>
+            <a:ext cx="3900000" cy="1150000"/>
+          </a:xfrm>
+          <a:prstGeom prst="roundRect">
+            <a:avLst/>
+          </a:prstGeom>
+          <a:solidFill>
+            <a:srgbClr val="12372A"/>
+          </a:solidFill>
+          <a:ln>
+            <a:noFill/>
+          </a:ln>
+        </p:spPr>
+        <p:txBody>
+          <a:bodyPr/>
+          <a:lstStyle/>
+          <a:p/>
+        </p:txBody>
+      </p:sp>
+      <p:sp>
+        <p:nvSpPr>
+          <p:cNvPr id="27" name="Text"/>
+          <p:cNvSpPr txBox="1"/>
+          <p:nvPr/>
+        </p:nvSpPr>
+        <p:spPr>
+          <a:xfrm>
+            <a:off x="8790000" y="5400000"/>
+            <a:ext cx="3320000" cy="540000"/>
+          </a:xfrm>
+          <a:prstGeom prst="rect">
+            <a:avLst/>
+          </a:prstGeom>
+          <a:noFill/>
+        </p:spPr>
+        <p:txBody>
+          <a:bodyPr wrap="square" anchor="t"/>
+          <a:lstStyle/>
+          <a:p>
+            <a:pPr algn="c"/>
             <a:r>
               <a:rPr lang="es-BO" sz="1950" dirty="0">
-                <a:solidFill>
-                  <a:srgbClr val="56635C"/>
-                </a:solidFill>
-                <a:latin typeface="Aptos"/>
-              </a:rPr>
-              <a:t>EcoBrief convierte informacion dispersa en briefs esenciales, medibles y de bajo costo.</a:t>
-            </a:r>
-          </a:p>
-        </p:txBody>
-      </p:sp>
-      <p:sp>
-        <p:nvSpPr>
-          <p:cNvPr id="16" name="Shape"/>
-          <p:cNvSpPr/>
-          <p:nvPr/>
-        </p:nvSpPr>
-        <p:spPr>
-          <a:xfrm>
-            <a:off x="770000" y="2702000"/>
-            <a:ext cx="95000" cy="95000"/>
-          </a:xfrm>
-          <a:prstGeom prst="ellipse">
-            <a:avLst/>
-          </a:prstGeom>
-          <a:solidFill>
-            <a:srgbClr val="1B7F5C"/>
-          </a:solidFill>
-          <a:ln>
-            <a:noFill/>
-          </a:ln>
-        </p:spPr>
-        <p:txBody>
-          <a:bodyPr/>
-          <a:lstStyle/>
-          <a:p/>
-        </p:txBody>
-      </p:sp>
-      <p:sp>
-        <p:nvSpPr>
-          <p:cNvPr id="17" name="Text"/>
-          <p:cNvSpPr txBox="1"/>
-          <p:nvPr/>
-        </p:nvSpPr>
-        <p:spPr>
-          <a:xfrm>
-            <a:off x="925000" y="2650000"/>
-            <a:ext cx="6695000" cy="260000"/>
-          </a:xfrm>
-          <a:prstGeom prst="rect">
-            <a:avLst/>
-          </a:prstGeom>
-          <a:noFill/>
-        </p:spPr>
-        <p:txBody>
-          <a:bodyPr wrap="square" anchor="t"/>
-          <a:lstStyle/>
-          <a:p>
-            <a:pPr algn="l"/>
-            <a:r>
-              <a:rPr lang="es-BO" sz="2150" dirty="0">
-                <a:solidFill>
-                  <a:srgbClr val="17211B"/>
-                </a:solidFill>
-                <a:latin typeface="Aptos"/>
-              </a:rPr>
-              <a:t>Resuelve un problema cotidiano.</a:t>
-            </a:r>
-          </a:p>
-        </p:txBody>
-      </p:sp>
-      <p:sp>
-        <p:nvSpPr>
-          <p:cNvPr id="18" name="Shape"/>
-          <p:cNvSpPr/>
-          <p:nvPr/>
-        </p:nvSpPr>
-        <p:spPr>
-          <a:xfrm>
-            <a:off x="770000" y="3087000"/>
-            <a:ext cx="95000" cy="95000"/>
-          </a:xfrm>
-          <a:prstGeom prst="ellipse">
-            <a:avLst/>
-          </a:prstGeom>
-          <a:solidFill>
-            <a:srgbClr val="1B7F5C"/>
-          </a:solidFill>
-          <a:ln>
-            <a:noFill/>
-          </a:ln>
-        </p:spPr>
-        <p:txBody>
-          <a:bodyPr/>
-          <a:lstStyle/>
-          <a:p/>
-        </p:txBody>
-      </p:sp>
-      <p:sp>
-        <p:nvSpPr>
-          <p:cNvPr id="19" name="Text"/>
-          <p:cNvSpPr txBox="1"/>
-          <p:nvPr/>
-        </p:nvSpPr>
-        <p:spPr>
-          <a:xfrm>
-            <a:off x="925000" y="3035000"/>
-            <a:ext cx="6695000" cy="260000"/>
-          </a:xfrm>
-          <a:prstGeom prst="rect">
-            <a:avLst/>
-          </a:prstGeom>
-          <a:noFill/>
-        </p:spPr>
-        <p:txBody>
-          <a:bodyPr wrap="square" anchor="t"/>
-          <a:lstStyle/>
-          <a:p>
-            <a:pPr algn="l"/>
-            <a:r>
-              <a:rPr lang="es-BO" sz="2150" dirty="0">
-                <a:solidFill>
-                  <a:srgbClr val="17211B"/>
-                </a:solidFill>
-                <a:latin typeface="Aptos"/>
-              </a:rPr>
-              <a:t>Encaja directamente con Green Tech.</a:t>
-            </a:r>
-          </a:p>
-        </p:txBody>
-      </p:sp>
-      <p:sp>
-        <p:nvSpPr>
-          <p:cNvPr id="20" name="Shape"/>
-          <p:cNvSpPr/>
-          <p:nvPr/>
-        </p:nvSpPr>
-        <p:spPr>
-          <a:xfrm>
-            <a:off x="770000" y="3472000"/>
-            <a:ext cx="95000" cy="95000"/>
-          </a:xfrm>
-          <a:prstGeom prst="ellipse">
-            <a:avLst/>
-          </a:prstGeom>
-          <a:solidFill>
-            <a:srgbClr val="1B7F5C"/>
-          </a:solidFill>
-          <a:ln>
-            <a:noFill/>
-          </a:ln>
-        </p:spPr>
-        <p:txBody>
-          <a:bodyPr/>
-          <a:lstStyle/>
-          <a:p/>
-        </p:txBody>
-      </p:sp>
-      <p:sp>
-        <p:nvSpPr>
-          <p:cNvPr id="21" name="Text"/>
-          <p:cNvSpPr txBox="1"/>
-          <p:nvPr/>
-        </p:nvSpPr>
-        <p:spPr>
-          <a:xfrm>
-            <a:off x="925000" y="3420000"/>
-            <a:ext cx="6695000" cy="260000"/>
-          </a:xfrm>
-          <a:prstGeom prst="rect">
-            <a:avLst/>
-          </a:prstGeom>
-          <a:noFill/>
-        </p:spPr>
-        <p:txBody>
-          <a:bodyPr wrap="square" anchor="t"/>
-          <a:lstStyle/>
-          <a:p>
-            <a:pPr algn="l"/>
-            <a:r>
-              <a:rPr lang="es-BO" sz="2150" dirty="0">
-                <a:solidFill>
-                  <a:srgbClr val="17211B"/>
-                </a:solidFill>
-                <a:latin typeface="Aptos"/>
-              </a:rPr>
-              <a:t>Tiene MVP funcional.</a:t>
-            </a:r>
-          </a:p>
-        </p:txBody>
-      </p:sp>
-      <p:sp>
-        <p:nvSpPr>
-          <p:cNvPr id="22" name="Shape"/>
-          <p:cNvSpPr/>
-          <p:nvPr/>
-        </p:nvSpPr>
-        <p:spPr>
-          <a:xfrm>
-            <a:off x="770000" y="3857000"/>
-            <a:ext cx="95000" cy="95000"/>
-          </a:xfrm>
-          <a:prstGeom prst="ellipse">
-            <a:avLst/>
-          </a:prstGeom>
-          <a:solidFill>
-            <a:srgbClr val="1B7F5C"/>
-          </a:solidFill>
-          <a:ln>
-            <a:noFill/>
-          </a:ln>
-        </p:spPr>
-        <p:txBody>
-          <a:bodyPr/>
-          <a:lstStyle/>
-          <a:p/>
-        </p:txBody>
-      </p:sp>
-      <p:sp>
-        <p:nvSpPr>
-          <p:cNvPr id="23" name="Text"/>
-          <p:cNvSpPr txBox="1"/>
-          <p:nvPr/>
-        </p:nvSpPr>
-        <p:spPr>
-          <a:xfrm>
-            <a:off x="925000" y="3805000"/>
-            <a:ext cx="6695000" cy="260000"/>
-          </a:xfrm>
-          <a:prstGeom prst="rect">
-            <a:avLst/>
-          </a:prstGeom>
-          <a:noFill/>
-        </p:spPr>
-        <p:txBody>
-          <a:bodyPr wrap="square" anchor="t"/>
-          <a:lstStyle/>
-          <a:p>
-            <a:pPr algn="l"/>
-            <a:r>
-              <a:rPr lang="es-BO" sz="2150" dirty="0">
-                <a:solidFill>
-                  <a:srgbClr val="17211B"/>
-                </a:solidFill>
-                <a:latin typeface="Aptos"/>
-              </a:rPr>
-              <a:t>Puede escalar con costos controlados.</a:t>
-            </a:r>
-          </a:p>
-        </p:txBody>
-      </p:sp>
-      <p:sp>
-        <p:nvSpPr>
-          <p:cNvPr id="24" name="Shape"/>
-          <p:cNvSpPr/>
-          <p:nvPr/>
-        </p:nvSpPr>
-        <p:spPr>
-          <a:xfrm>
-            <a:off x="770000" y="4242000"/>
-            <a:ext cx="95000" cy="95000"/>
-          </a:xfrm>
-          <a:prstGeom prst="ellipse">
-            <a:avLst/>
-          </a:prstGeom>
-          <a:solidFill>
-            <a:srgbClr val="1B7F5C"/>
-          </a:solidFill>
-          <a:ln>
-            <a:noFill/>
-          </a:ln>
-        </p:spPr>
-        <p:txBody>
-          <a:bodyPr/>
-          <a:lstStyle/>
-          <a:p/>
-        </p:txBody>
-      </p:sp>
-      <p:sp>
-        <p:nvSpPr>
-          <p:cNvPr id="25" name="Text"/>
-          <p:cNvSpPr txBox="1"/>
-          <p:nvPr/>
-        </p:nvSpPr>
-        <p:spPr>
-          <a:xfrm>
-            <a:off x="925000" y="4190000"/>
-            <a:ext cx="6695000" cy="260000"/>
-          </a:xfrm>
-          <a:prstGeom prst="rect">
-            <a:avLst/>
-          </a:prstGeom>
-          <a:noFill/>
-        </p:spPr>
-        <p:txBody>
-          <a:bodyPr wrap="square" anchor="t"/>
-          <a:lstStyle/>
-          <a:p>
-            <a:pPr algn="l"/>
-            <a:r>
-              <a:rPr lang="es-BO" sz="2150" dirty="0">
-                <a:solidFill>
-                  <a:srgbClr val="17211B"/>
-                </a:solidFill>
-                <a:latin typeface="Aptos"/>
-              </a:rPr>
-              <a:t>Convierte impacto digital en metricas visibles.</a:t>
-            </a:r>
-          </a:p>
-        </p:txBody>
-      </p:sp>
-      <p:sp>
-        <p:nvSpPr>
-          <p:cNvPr id="26" name="Shape"/>
-          <p:cNvSpPr/>
-          <p:nvPr/>
-        </p:nvSpPr>
-        <p:spPr>
-          <a:xfrm>
-            <a:off x="8500000" y="4920000"/>
-            <a:ext cx="3900000" cy="1150000"/>
-          </a:xfrm>
-          <a:prstGeom prst="roundRect">
-            <a:avLst/>
-          </a:prstGeom>
-          <a:solidFill>
-            <a:srgbClr val="12372A"/>
-          </a:solidFill>
-          <a:ln>
-            <a:noFill/>
-          </a:ln>
-        </p:spPr>
-        <p:txBody>
-          <a:bodyPr/>
-          <a:lstStyle/>
-          <a:p/>
-        </p:txBody>
-      </p:sp>
-      <p:sp>
-        <p:nvSpPr>
-          <p:cNvPr id="27" name="Text"/>
-          <p:cNvSpPr txBox="1"/>
-          <p:nvPr/>
-        </p:nvSpPr>
-        <p:spPr>
-          <a:xfrm>
-            <a:off x="8790000" y="5180000"/>
-            <a:ext cx="3320000" cy="540000"/>
-          </a:xfrm>
-          <a:prstGeom prst="rect">
-            <a:avLst/>
-          </a:prstGeom>
-          <a:noFill/>
-        </p:spPr>
-        <p:txBody>
-          <a:bodyPr wrap="square" anchor="t"/>
-          <a:lstStyle/>
-          <a:p>
-            <a:pPr algn="c"/>
-            <a:r>
-              <a:rPr lang="es-BO" sz="2050" dirty="0">
                 <a:b/>
                 <a:solidFill>
                   <a:srgbClr val="FFFFFF"/>
@@ -2271,21 +2271,21 @@
         </p:nvSpPr>
         <p:spPr>
           <a:xfrm>
-            <a:off x="620000" y="775000"/>
-            <a:ext cx="7700000" cy="980000"/>
-          </a:xfrm>
-          <a:prstGeom prst="rect">
-            <a:avLst/>
-          </a:prstGeom>
-          <a:noFill/>
-        </p:spPr>
-        <p:txBody>
-          <a:bodyPr wrap="square" anchor="t"/>
-          <a:lstStyle/>
-          <a:p>
-            <a:pPr algn="l"/>
-            <a:r>
-              <a:rPr lang="es-BO" sz="4050" dirty="0">
+            <a:off x="620000" y="760000"/>
+            <a:ext cx="8250000" cy="1260000"/>
+          </a:xfrm>
+          <a:prstGeom prst="rect">
+            <a:avLst/>
+          </a:prstGeom>
+          <a:noFill/>
+        </p:spPr>
+        <p:txBody>
+          <a:bodyPr wrap="square" anchor="t"/>
+          <a:lstStyle/>
+          <a:p>
+            <a:pPr algn="l"/>
+            <a:r>
+              <a:rPr lang="es-BO" sz="3450" dirty="0">
                 <a:b/>
                 <a:solidFill>
                   <a:srgbClr val="12372A"/>
@@ -2305,441 +2305,441 @@
         </p:nvSpPr>
         <p:spPr>
           <a:xfrm>
-            <a:off x="630000" y="1710000"/>
-            <a:ext cx="7850000" cy="570000"/>
-          </a:xfrm>
-          <a:prstGeom prst="rect">
-            <a:avLst/>
-          </a:prstGeom>
-          <a:noFill/>
-        </p:spPr>
-        <p:txBody>
-          <a:bodyPr wrap="square" anchor="t"/>
-          <a:lstStyle/>
-          <a:p>
-            <a:pPr algn="l"/>
+            <a:off x="630000" y="2140000"/>
+            <a:ext cx="8350000" cy="620000"/>
+          </a:xfrm>
+          <a:prstGeom prst="rect">
+            <a:avLst/>
+          </a:prstGeom>
+          <a:noFill/>
+        </p:spPr>
+        <p:txBody>
+          <a:bodyPr wrap="square" anchor="t"/>
+          <a:lstStyle/>
+          <a:p>
+            <a:pPr algn="l"/>
+            <a:r>
+              <a:rPr lang="es-BO" sz="1850" dirty="0">
+                <a:solidFill>
+                  <a:srgbClr val="56635C"/>
+                </a:solidFill>
+                <a:latin typeface="Aptos"/>
+              </a:rPr>
+              <a:t>El problema no es falta de informacion. Es exceso de informacion redundante.</a:t>
+            </a:r>
+          </a:p>
+        </p:txBody>
+      </p:sp>
+      <p:sp>
+        <p:nvSpPr>
+          <p:cNvPr id="16" name="Shape"/>
+          <p:cNvSpPr/>
+          <p:nvPr/>
+        </p:nvSpPr>
+        <p:spPr>
+          <a:xfrm>
+            <a:off x="770000" y="3082000"/>
+            <a:ext cx="95000" cy="95000"/>
+          </a:xfrm>
+          <a:prstGeom prst="ellipse">
+            <a:avLst/>
+          </a:prstGeom>
+          <a:solidFill>
+            <a:srgbClr val="1B7F5C"/>
+          </a:solidFill>
+          <a:ln>
+            <a:noFill/>
+          </a:ln>
+        </p:spPr>
+        <p:txBody>
+          <a:bodyPr/>
+          <a:lstStyle/>
+          <a:p/>
+        </p:txBody>
+      </p:sp>
+      <p:sp>
+        <p:nvSpPr>
+          <p:cNvPr id="17" name="Text"/>
+          <p:cNvSpPr txBox="1"/>
+          <p:nvPr/>
+        </p:nvSpPr>
+        <p:spPr>
+          <a:xfrm>
+            <a:off x="925000" y="3030000"/>
+            <a:ext cx="6695000" cy="260000"/>
+          </a:xfrm>
+          <a:prstGeom prst="rect">
+            <a:avLst/>
+          </a:prstGeom>
+          <a:noFill/>
+        </p:spPr>
+        <p:txBody>
+          <a:bodyPr wrap="square" anchor="t"/>
+          <a:lstStyle/>
+          <a:p>
+            <a:pPr algn="l"/>
+            <a:r>
+              <a:rPr lang="es-BO" sz="2150" dirty="0">
+                <a:solidFill>
+                  <a:srgbClr val="17211B"/>
+                </a:solidFill>
+                <a:latin typeface="Aptos"/>
+              </a:rPr>
+              <a:t>Una misma historia se repite en varios medios.</a:t>
+            </a:r>
+          </a:p>
+        </p:txBody>
+      </p:sp>
+      <p:sp>
+        <p:nvSpPr>
+          <p:cNvPr id="18" name="Shape"/>
+          <p:cNvSpPr/>
+          <p:nvPr/>
+        </p:nvSpPr>
+        <p:spPr>
+          <a:xfrm>
+            <a:off x="770000" y="3467000"/>
+            <a:ext cx="95000" cy="95000"/>
+          </a:xfrm>
+          <a:prstGeom prst="ellipse">
+            <a:avLst/>
+          </a:prstGeom>
+          <a:solidFill>
+            <a:srgbClr val="1B7F5C"/>
+          </a:solidFill>
+          <a:ln>
+            <a:noFill/>
+          </a:ln>
+        </p:spPr>
+        <p:txBody>
+          <a:bodyPr/>
+          <a:lstStyle/>
+          <a:p/>
+        </p:txBody>
+      </p:sp>
+      <p:sp>
+        <p:nvSpPr>
+          <p:cNvPr id="19" name="Text"/>
+          <p:cNvSpPr txBox="1"/>
+          <p:nvPr/>
+        </p:nvSpPr>
+        <p:spPr>
+          <a:xfrm>
+            <a:off x="925000" y="3415000"/>
+            <a:ext cx="6695000" cy="260000"/>
+          </a:xfrm>
+          <a:prstGeom prst="rect">
+            <a:avLst/>
+          </a:prstGeom>
+          <a:noFill/>
+        </p:spPr>
+        <p:txBody>
+          <a:bodyPr wrap="square" anchor="t"/>
+          <a:lstStyle/>
+          <a:p>
+            <a:pPr algn="l"/>
+            <a:r>
+              <a:rPr lang="es-BO" sz="2150" dirty="0">
+                <a:solidFill>
+                  <a:srgbClr val="17211B"/>
+                </a:solidFill>
+                <a:latin typeface="Aptos"/>
+              </a:rPr>
+              <a:t>El usuario abre multiples paginas para entender un hecho.</a:t>
+            </a:r>
+          </a:p>
+        </p:txBody>
+      </p:sp>
+      <p:sp>
+        <p:nvSpPr>
+          <p:cNvPr id="20" name="Shape"/>
+          <p:cNvSpPr/>
+          <p:nvPr/>
+        </p:nvSpPr>
+        <p:spPr>
+          <a:xfrm>
+            <a:off x="770000" y="3852000"/>
+            <a:ext cx="95000" cy="95000"/>
+          </a:xfrm>
+          <a:prstGeom prst="ellipse">
+            <a:avLst/>
+          </a:prstGeom>
+          <a:solidFill>
+            <a:srgbClr val="1B7F5C"/>
+          </a:solidFill>
+          <a:ln>
+            <a:noFill/>
+          </a:ln>
+        </p:spPr>
+        <p:txBody>
+          <a:bodyPr/>
+          <a:lstStyle/>
+          <a:p/>
+        </p:txBody>
+      </p:sp>
+      <p:sp>
+        <p:nvSpPr>
+          <p:cNvPr id="21" name="Text"/>
+          <p:cNvSpPr txBox="1"/>
+          <p:nvPr/>
+        </p:nvSpPr>
+        <p:spPr>
+          <a:xfrm>
+            <a:off x="925000" y="3800000"/>
+            <a:ext cx="6695000" cy="260000"/>
+          </a:xfrm>
+          <a:prstGeom prst="rect">
+            <a:avLst/>
+          </a:prstGeom>
+          <a:noFill/>
+        </p:spPr>
+        <p:txBody>
+          <a:bodyPr wrap="square" anchor="t"/>
+          <a:lstStyle/>
+          <a:p>
+            <a:pPr algn="l"/>
+            <a:r>
+              <a:rPr lang="es-BO" sz="2150" dirty="0">
+                <a:solidFill>
+                  <a:srgbClr val="17211B"/>
+                </a:solidFill>
+                <a:latin typeface="Aptos"/>
+              </a:rPr>
+              <a:t>Muchas personas buscan contexto en TikTok, Facebook u otros feeds.</a:t>
+            </a:r>
+          </a:p>
+        </p:txBody>
+      </p:sp>
+      <p:sp>
+        <p:nvSpPr>
+          <p:cNvPr id="22" name="Shape"/>
+          <p:cNvSpPr/>
+          <p:nvPr/>
+        </p:nvSpPr>
+        <p:spPr>
+          <a:xfrm>
+            <a:off x="770000" y="4237000"/>
+            <a:ext cx="95000" cy="95000"/>
+          </a:xfrm>
+          <a:prstGeom prst="ellipse">
+            <a:avLst/>
+          </a:prstGeom>
+          <a:solidFill>
+            <a:srgbClr val="1B7F5C"/>
+          </a:solidFill>
+          <a:ln>
+            <a:noFill/>
+          </a:ln>
+        </p:spPr>
+        <p:txBody>
+          <a:bodyPr/>
+          <a:lstStyle/>
+          <a:p/>
+        </p:txBody>
+      </p:sp>
+      <p:sp>
+        <p:nvSpPr>
+          <p:cNvPr id="23" name="Text"/>
+          <p:cNvSpPr txBox="1"/>
+          <p:nvPr/>
+        </p:nvSpPr>
+        <p:spPr>
+          <a:xfrm>
+            <a:off x="925000" y="4185000"/>
+            <a:ext cx="6695000" cy="260000"/>
+          </a:xfrm>
+          <a:prstGeom prst="rect">
+            <a:avLst/>
+          </a:prstGeom>
+          <a:noFill/>
+        </p:spPr>
+        <p:txBody>
+          <a:bodyPr wrap="square" anchor="t"/>
+          <a:lstStyle/>
+          <a:p>
+            <a:pPr algn="l"/>
+            <a:r>
+              <a:rPr lang="es-BO" sz="2150" dirty="0">
+                <a:solidFill>
+                  <a:srgbClr val="17211B"/>
+                </a:solidFill>
+                <a:latin typeface="Aptos"/>
+              </a:rPr>
+              <a:t>En redes, la informacion puede aparecer fragmentada o sin fuente clara.</a:t>
+            </a:r>
+          </a:p>
+        </p:txBody>
+      </p:sp>
+      <p:sp>
+        <p:nvSpPr>
+          <p:cNvPr id="24" name="Shape"/>
+          <p:cNvSpPr/>
+          <p:nvPr/>
+        </p:nvSpPr>
+        <p:spPr>
+          <a:xfrm>
+            <a:off x="770000" y="4622000"/>
+            <a:ext cx="95000" cy="95000"/>
+          </a:xfrm>
+          <a:prstGeom prst="ellipse">
+            <a:avLst/>
+          </a:prstGeom>
+          <a:solidFill>
+            <a:srgbClr val="1B7F5C"/>
+          </a:solidFill>
+          <a:ln>
+            <a:noFill/>
+          </a:ln>
+        </p:spPr>
+        <p:txBody>
+          <a:bodyPr/>
+          <a:lstStyle/>
+          <a:p/>
+        </p:txBody>
+      </p:sp>
+      <p:sp>
+        <p:nvSpPr>
+          <p:cNvPr id="25" name="Text"/>
+          <p:cNvSpPr txBox="1"/>
+          <p:nvPr/>
+        </p:nvSpPr>
+        <p:spPr>
+          <a:xfrm>
+            <a:off x="925000" y="4570000"/>
+            <a:ext cx="6695000" cy="260000"/>
+          </a:xfrm>
+          <a:prstGeom prst="rect">
+            <a:avLst/>
+          </a:prstGeom>
+          <a:noFill/>
+        </p:spPr>
+        <p:txBody>
+          <a:bodyPr wrap="square" anchor="t"/>
+          <a:lstStyle/>
+          <a:p>
+            <a:pPr algn="l"/>
+            <a:r>
+              <a:rPr lang="es-BO" sz="2150" dirty="0">
+                <a:solidFill>
+                  <a:srgbClr val="17211B"/>
+                </a:solidFill>
+                <a:latin typeface="Aptos"/>
+              </a:rPr>
+              <a:t>Cada pagina carga imagenes, scripts, publicidad y trackers.</a:t>
+            </a:r>
+          </a:p>
+        </p:txBody>
+      </p:sp>
+      <p:sp>
+        <p:nvSpPr>
+          <p:cNvPr id="26" name="Shape"/>
+          <p:cNvSpPr/>
+          <p:nvPr/>
+        </p:nvSpPr>
+        <p:spPr>
+          <a:xfrm>
+            <a:off x="770000" y="5007000"/>
+            <a:ext cx="95000" cy="95000"/>
+          </a:xfrm>
+          <a:prstGeom prst="ellipse">
+            <a:avLst/>
+          </a:prstGeom>
+          <a:solidFill>
+            <a:srgbClr val="1B7F5C"/>
+          </a:solidFill>
+          <a:ln>
+            <a:noFill/>
+          </a:ln>
+        </p:spPr>
+        <p:txBody>
+          <a:bodyPr/>
+          <a:lstStyle/>
+          <a:p/>
+        </p:txBody>
+      </p:sp>
+      <p:sp>
+        <p:nvSpPr>
+          <p:cNvPr id="27" name="Text"/>
+          <p:cNvSpPr txBox="1"/>
+          <p:nvPr/>
+        </p:nvSpPr>
+        <p:spPr>
+          <a:xfrm>
+            <a:off x="925000" y="4955000"/>
+            <a:ext cx="6695000" cy="260000"/>
+          </a:xfrm>
+          <a:prstGeom prst="rect">
+            <a:avLst/>
+          </a:prstGeom>
+          <a:noFill/>
+        </p:spPr>
+        <p:txBody>
+          <a:bodyPr wrap="square" anchor="t"/>
+          <a:lstStyle/>
+          <a:p>
+            <a:pPr algn="l"/>
+            <a:r>
+              <a:rPr lang="es-BO" sz="2150" dirty="0">
+                <a:solidFill>
+                  <a:srgbClr val="17211B"/>
+                </a:solidFill>
+                <a:latin typeface="Aptos"/>
+              </a:rPr>
+              <a:t>La IA desperdicia tokens si procesa contenido repetido.</a:t>
+            </a:r>
+          </a:p>
+        </p:txBody>
+      </p:sp>
+      <p:sp>
+        <p:nvSpPr>
+          <p:cNvPr id="28" name="Shape"/>
+          <p:cNvSpPr/>
+          <p:nvPr/>
+        </p:nvSpPr>
+        <p:spPr>
+          <a:xfrm>
+            <a:off x="8500000" y="5140000"/>
+            <a:ext cx="3900000" cy="1150000"/>
+          </a:xfrm>
+          <a:prstGeom prst="roundRect">
+            <a:avLst/>
+          </a:prstGeom>
+          <a:solidFill>
+            <a:srgbClr val="12372A"/>
+          </a:solidFill>
+          <a:ln>
+            <a:noFill/>
+          </a:ln>
+        </p:spPr>
+        <p:txBody>
+          <a:bodyPr/>
+          <a:lstStyle/>
+          <a:p/>
+        </p:txBody>
+      </p:sp>
+      <p:sp>
+        <p:nvSpPr>
+          <p:cNvPr id="29" name="Text"/>
+          <p:cNvSpPr txBox="1"/>
+          <p:nvPr/>
+        </p:nvSpPr>
+        <p:spPr>
+          <a:xfrm>
+            <a:off x="8790000" y="5400000"/>
+            <a:ext cx="3320000" cy="540000"/>
+          </a:xfrm>
+          <a:prstGeom prst="rect">
+            <a:avLst/>
+          </a:prstGeom>
+          <a:noFill/>
+        </p:spPr>
+        <p:txBody>
+          <a:bodyPr wrap="square" anchor="t"/>
+          <a:lstStyle/>
+          <a:p>
+            <a:pPr algn="c"/>
             <a:r>
               <a:rPr lang="es-BO" sz="1950" dirty="0">
-                <a:solidFill>
-                  <a:srgbClr val="56635C"/>
-                </a:solidFill>
-                <a:latin typeface="Aptos"/>
-              </a:rPr>
-              <a:t>El problema no es falta de informacion. Es exceso de informacion redundante.</a:t>
-            </a:r>
-          </a:p>
-        </p:txBody>
-      </p:sp>
-      <p:sp>
-        <p:nvSpPr>
-          <p:cNvPr id="16" name="Shape"/>
-          <p:cNvSpPr/>
-          <p:nvPr/>
-        </p:nvSpPr>
-        <p:spPr>
-          <a:xfrm>
-            <a:off x="770000" y="2702000"/>
-            <a:ext cx="95000" cy="95000"/>
-          </a:xfrm>
-          <a:prstGeom prst="ellipse">
-            <a:avLst/>
-          </a:prstGeom>
-          <a:solidFill>
-            <a:srgbClr val="1B7F5C"/>
-          </a:solidFill>
-          <a:ln>
-            <a:noFill/>
-          </a:ln>
-        </p:spPr>
-        <p:txBody>
-          <a:bodyPr/>
-          <a:lstStyle/>
-          <a:p/>
-        </p:txBody>
-      </p:sp>
-      <p:sp>
-        <p:nvSpPr>
-          <p:cNvPr id="17" name="Text"/>
-          <p:cNvSpPr txBox="1"/>
-          <p:nvPr/>
-        </p:nvSpPr>
-        <p:spPr>
-          <a:xfrm>
-            <a:off x="925000" y="2650000"/>
-            <a:ext cx="6695000" cy="260000"/>
-          </a:xfrm>
-          <a:prstGeom prst="rect">
-            <a:avLst/>
-          </a:prstGeom>
-          <a:noFill/>
-        </p:spPr>
-        <p:txBody>
-          <a:bodyPr wrap="square" anchor="t"/>
-          <a:lstStyle/>
-          <a:p>
-            <a:pPr algn="l"/>
-            <a:r>
-              <a:rPr lang="es-BO" sz="2150" dirty="0">
-                <a:solidFill>
-                  <a:srgbClr val="17211B"/>
-                </a:solidFill>
-                <a:latin typeface="Aptos"/>
-              </a:rPr>
-              <a:t>Una misma historia se repite en varios medios.</a:t>
-            </a:r>
-          </a:p>
-        </p:txBody>
-      </p:sp>
-      <p:sp>
-        <p:nvSpPr>
-          <p:cNvPr id="18" name="Shape"/>
-          <p:cNvSpPr/>
-          <p:nvPr/>
-        </p:nvSpPr>
-        <p:spPr>
-          <a:xfrm>
-            <a:off x="770000" y="3087000"/>
-            <a:ext cx="95000" cy="95000"/>
-          </a:xfrm>
-          <a:prstGeom prst="ellipse">
-            <a:avLst/>
-          </a:prstGeom>
-          <a:solidFill>
-            <a:srgbClr val="1B7F5C"/>
-          </a:solidFill>
-          <a:ln>
-            <a:noFill/>
-          </a:ln>
-        </p:spPr>
-        <p:txBody>
-          <a:bodyPr/>
-          <a:lstStyle/>
-          <a:p/>
-        </p:txBody>
-      </p:sp>
-      <p:sp>
-        <p:nvSpPr>
-          <p:cNvPr id="19" name="Text"/>
-          <p:cNvSpPr txBox="1"/>
-          <p:nvPr/>
-        </p:nvSpPr>
-        <p:spPr>
-          <a:xfrm>
-            <a:off x="925000" y="3035000"/>
-            <a:ext cx="6695000" cy="260000"/>
-          </a:xfrm>
-          <a:prstGeom prst="rect">
-            <a:avLst/>
-          </a:prstGeom>
-          <a:noFill/>
-        </p:spPr>
-        <p:txBody>
-          <a:bodyPr wrap="square" anchor="t"/>
-          <a:lstStyle/>
-          <a:p>
-            <a:pPr algn="l"/>
-            <a:r>
-              <a:rPr lang="es-BO" sz="2150" dirty="0">
-                <a:solidFill>
-                  <a:srgbClr val="17211B"/>
-                </a:solidFill>
-                <a:latin typeface="Aptos"/>
-              </a:rPr>
-              <a:t>El usuario abre multiples paginas para entender un hecho.</a:t>
-            </a:r>
-          </a:p>
-        </p:txBody>
-      </p:sp>
-      <p:sp>
-        <p:nvSpPr>
-          <p:cNvPr id="20" name="Shape"/>
-          <p:cNvSpPr/>
-          <p:nvPr/>
-        </p:nvSpPr>
-        <p:spPr>
-          <a:xfrm>
-            <a:off x="770000" y="3472000"/>
-            <a:ext cx="95000" cy="95000"/>
-          </a:xfrm>
-          <a:prstGeom prst="ellipse">
-            <a:avLst/>
-          </a:prstGeom>
-          <a:solidFill>
-            <a:srgbClr val="1B7F5C"/>
-          </a:solidFill>
-          <a:ln>
-            <a:noFill/>
-          </a:ln>
-        </p:spPr>
-        <p:txBody>
-          <a:bodyPr/>
-          <a:lstStyle/>
-          <a:p/>
-        </p:txBody>
-      </p:sp>
-      <p:sp>
-        <p:nvSpPr>
-          <p:cNvPr id="21" name="Text"/>
-          <p:cNvSpPr txBox="1"/>
-          <p:nvPr/>
-        </p:nvSpPr>
-        <p:spPr>
-          <a:xfrm>
-            <a:off x="925000" y="3420000"/>
-            <a:ext cx="6695000" cy="260000"/>
-          </a:xfrm>
-          <a:prstGeom prst="rect">
-            <a:avLst/>
-          </a:prstGeom>
-          <a:noFill/>
-        </p:spPr>
-        <p:txBody>
-          <a:bodyPr wrap="square" anchor="t"/>
-          <a:lstStyle/>
-          <a:p>
-            <a:pPr algn="l"/>
-            <a:r>
-              <a:rPr lang="es-BO" sz="2150" dirty="0">
-                <a:solidFill>
-                  <a:srgbClr val="17211B"/>
-                </a:solidFill>
-                <a:latin typeface="Aptos"/>
-              </a:rPr>
-              <a:t>Muchas personas buscan contexto en TikTok, Facebook u otros feeds.</a:t>
-            </a:r>
-          </a:p>
-        </p:txBody>
-      </p:sp>
-      <p:sp>
-        <p:nvSpPr>
-          <p:cNvPr id="22" name="Shape"/>
-          <p:cNvSpPr/>
-          <p:nvPr/>
-        </p:nvSpPr>
-        <p:spPr>
-          <a:xfrm>
-            <a:off x="770000" y="3857000"/>
-            <a:ext cx="95000" cy="95000"/>
-          </a:xfrm>
-          <a:prstGeom prst="ellipse">
-            <a:avLst/>
-          </a:prstGeom>
-          <a:solidFill>
-            <a:srgbClr val="1B7F5C"/>
-          </a:solidFill>
-          <a:ln>
-            <a:noFill/>
-          </a:ln>
-        </p:spPr>
-        <p:txBody>
-          <a:bodyPr/>
-          <a:lstStyle/>
-          <a:p/>
-        </p:txBody>
-      </p:sp>
-      <p:sp>
-        <p:nvSpPr>
-          <p:cNvPr id="23" name="Text"/>
-          <p:cNvSpPr txBox="1"/>
-          <p:nvPr/>
-        </p:nvSpPr>
-        <p:spPr>
-          <a:xfrm>
-            <a:off x="925000" y="3805000"/>
-            <a:ext cx="6695000" cy="260000"/>
-          </a:xfrm>
-          <a:prstGeom prst="rect">
-            <a:avLst/>
-          </a:prstGeom>
-          <a:noFill/>
-        </p:spPr>
-        <p:txBody>
-          <a:bodyPr wrap="square" anchor="t"/>
-          <a:lstStyle/>
-          <a:p>
-            <a:pPr algn="l"/>
-            <a:r>
-              <a:rPr lang="es-BO" sz="2150" dirty="0">
-                <a:solidFill>
-                  <a:srgbClr val="17211B"/>
-                </a:solidFill>
-                <a:latin typeface="Aptos"/>
-              </a:rPr>
-              <a:t>En redes, la informacion puede aparecer fragmentada o sin fuente clara.</a:t>
-            </a:r>
-          </a:p>
-        </p:txBody>
-      </p:sp>
-      <p:sp>
-        <p:nvSpPr>
-          <p:cNvPr id="24" name="Shape"/>
-          <p:cNvSpPr/>
-          <p:nvPr/>
-        </p:nvSpPr>
-        <p:spPr>
-          <a:xfrm>
-            <a:off x="770000" y="4242000"/>
-            <a:ext cx="95000" cy="95000"/>
-          </a:xfrm>
-          <a:prstGeom prst="ellipse">
-            <a:avLst/>
-          </a:prstGeom>
-          <a:solidFill>
-            <a:srgbClr val="1B7F5C"/>
-          </a:solidFill>
-          <a:ln>
-            <a:noFill/>
-          </a:ln>
-        </p:spPr>
-        <p:txBody>
-          <a:bodyPr/>
-          <a:lstStyle/>
-          <a:p/>
-        </p:txBody>
-      </p:sp>
-      <p:sp>
-        <p:nvSpPr>
-          <p:cNvPr id="25" name="Text"/>
-          <p:cNvSpPr txBox="1"/>
-          <p:nvPr/>
-        </p:nvSpPr>
-        <p:spPr>
-          <a:xfrm>
-            <a:off x="925000" y="4190000"/>
-            <a:ext cx="6695000" cy="260000"/>
-          </a:xfrm>
-          <a:prstGeom prst="rect">
-            <a:avLst/>
-          </a:prstGeom>
-          <a:noFill/>
-        </p:spPr>
-        <p:txBody>
-          <a:bodyPr wrap="square" anchor="t"/>
-          <a:lstStyle/>
-          <a:p>
-            <a:pPr algn="l"/>
-            <a:r>
-              <a:rPr lang="es-BO" sz="2150" dirty="0">
-                <a:solidFill>
-                  <a:srgbClr val="17211B"/>
-                </a:solidFill>
-                <a:latin typeface="Aptos"/>
-              </a:rPr>
-              <a:t>Cada pagina carga imagenes, scripts, publicidad y trackers.</a:t>
-            </a:r>
-          </a:p>
-        </p:txBody>
-      </p:sp>
-      <p:sp>
-        <p:nvSpPr>
-          <p:cNvPr id="26" name="Shape"/>
-          <p:cNvSpPr/>
-          <p:nvPr/>
-        </p:nvSpPr>
-        <p:spPr>
-          <a:xfrm>
-            <a:off x="770000" y="4627000"/>
-            <a:ext cx="95000" cy="95000"/>
-          </a:xfrm>
-          <a:prstGeom prst="ellipse">
-            <a:avLst/>
-          </a:prstGeom>
-          <a:solidFill>
-            <a:srgbClr val="1B7F5C"/>
-          </a:solidFill>
-          <a:ln>
-            <a:noFill/>
-          </a:ln>
-        </p:spPr>
-        <p:txBody>
-          <a:bodyPr/>
-          <a:lstStyle/>
-          <a:p/>
-        </p:txBody>
-      </p:sp>
-      <p:sp>
-        <p:nvSpPr>
-          <p:cNvPr id="27" name="Text"/>
-          <p:cNvSpPr txBox="1"/>
-          <p:nvPr/>
-        </p:nvSpPr>
-        <p:spPr>
-          <a:xfrm>
-            <a:off x="925000" y="4575000"/>
-            <a:ext cx="6695000" cy="260000"/>
-          </a:xfrm>
-          <a:prstGeom prst="rect">
-            <a:avLst/>
-          </a:prstGeom>
-          <a:noFill/>
-        </p:spPr>
-        <p:txBody>
-          <a:bodyPr wrap="square" anchor="t"/>
-          <a:lstStyle/>
-          <a:p>
-            <a:pPr algn="l"/>
-            <a:r>
-              <a:rPr lang="es-BO" sz="2150" dirty="0">
-                <a:solidFill>
-                  <a:srgbClr val="17211B"/>
-                </a:solidFill>
-                <a:latin typeface="Aptos"/>
-              </a:rPr>
-              <a:t>La IA desperdicia tokens si procesa contenido repetido.</a:t>
-            </a:r>
-          </a:p>
-        </p:txBody>
-      </p:sp>
-      <p:sp>
-        <p:nvSpPr>
-          <p:cNvPr id="28" name="Shape"/>
-          <p:cNvSpPr/>
-          <p:nvPr/>
-        </p:nvSpPr>
-        <p:spPr>
-          <a:xfrm>
-            <a:off x="8500000" y="4920000"/>
-            <a:ext cx="3900000" cy="1150000"/>
-          </a:xfrm>
-          <a:prstGeom prst="roundRect">
-            <a:avLst/>
-          </a:prstGeom>
-          <a:solidFill>
-            <a:srgbClr val="12372A"/>
-          </a:solidFill>
-          <a:ln>
-            <a:noFill/>
-          </a:ln>
-        </p:spPr>
-        <p:txBody>
-          <a:bodyPr/>
-          <a:lstStyle/>
-          <a:p/>
-        </p:txBody>
-      </p:sp>
-      <p:sp>
-        <p:nvSpPr>
-          <p:cNvPr id="29" name="Text"/>
-          <p:cNvSpPr txBox="1"/>
-          <p:nvPr/>
-        </p:nvSpPr>
-        <p:spPr>
-          <a:xfrm>
-            <a:off x="8790000" y="5180000"/>
-            <a:ext cx="3320000" cy="540000"/>
-          </a:xfrm>
-          <a:prstGeom prst="rect">
-            <a:avLst/>
-          </a:prstGeom>
-          <a:noFill/>
-        </p:spPr>
-        <p:txBody>
-          <a:bodyPr wrap="square" anchor="t"/>
-          <a:lstStyle/>
-          <a:p>
-            <a:pPr algn="c"/>
-            <a:r>
-              <a:rPr lang="es-BO" sz="2050" dirty="0">
                 <a:b/>
                 <a:solidFill>
                   <a:srgbClr val="FFFFFF"/>
@@ -2906,21 +2906,21 @@
         </p:nvSpPr>
         <p:spPr>
           <a:xfrm>
-            <a:off x="620000" y="775000"/>
-            <a:ext cx="7700000" cy="980000"/>
-          </a:xfrm>
-          <a:prstGeom prst="rect">
-            <a:avLst/>
-          </a:prstGeom>
-          <a:noFill/>
-        </p:spPr>
-        <p:txBody>
-          <a:bodyPr wrap="square" anchor="t"/>
-          <a:lstStyle/>
-          <a:p>
-            <a:pPr algn="l"/>
-            <a:r>
-              <a:rPr lang="es-BO" sz="4050" dirty="0">
+            <a:off x="620000" y="760000"/>
+            <a:ext cx="8250000" cy="1260000"/>
+          </a:xfrm>
+          <a:prstGeom prst="rect">
+            <a:avLst/>
+          </a:prstGeom>
+          <a:noFill/>
+        </p:spPr>
+        <p:txBody>
+          <a:bodyPr wrap="square" anchor="t"/>
+          <a:lstStyle/>
+          <a:p>
+            <a:pPr algn="l"/>
+            <a:r>
+              <a:rPr lang="es-BO" sz="3450" dirty="0">
                 <a:b/>
                 <a:solidFill>
                   <a:srgbClr val="12372A"/>
@@ -2940,21 +2940,21 @@
         </p:nvSpPr>
         <p:spPr>
           <a:xfrm>
-            <a:off x="630000" y="1710000"/>
-            <a:ext cx="7850000" cy="570000"/>
-          </a:xfrm>
-          <a:prstGeom prst="rect">
-            <a:avLst/>
-          </a:prstGeom>
-          <a:noFill/>
-        </p:spPr>
-        <p:txBody>
-          <a:bodyPr wrap="square" anchor="t"/>
-          <a:lstStyle/>
-          <a:p>
-            <a:pPr algn="l"/>
-            <a:r>
-              <a:rPr lang="es-BO" sz="1950" dirty="0">
+            <a:off x="630000" y="2140000"/>
+            <a:ext cx="8350000" cy="620000"/>
+          </a:xfrm>
+          <a:prstGeom prst="rect">
+            <a:avLst/>
+          </a:prstGeom>
+          <a:noFill/>
+        </p:spPr>
+        <p:txBody>
+          <a:bodyPr wrap="square" anchor="t"/>
+          <a:lstStyle/>
+          <a:p>
+            <a:pPr algn="l"/>
+            <a:r>
+              <a:rPr lang="es-BO" sz="1850" dirty="0">
                 <a:solidFill>
                   <a:srgbClr val="56635C"/>
                 </a:solidFill>
@@ -2973,8 +2973,8 @@
         </p:nvSpPr>
         <p:spPr>
           <a:xfrm>
-            <a:off x="820000" y="2680000"/>
-            <a:ext cx="4950000" cy="3520000"/>
+            <a:off x="820000" y="3030000"/>
+            <a:ext cx="4950000" cy="3220000"/>
           </a:xfrm>
           <a:prstGeom prst="roundRect">
             <a:avLst/>
@@ -3002,21 +3002,21 @@
         </p:nvSpPr>
         <p:spPr>
           <a:xfrm>
-            <a:off x="1080000" y="2930000"/>
-            <a:ext cx="4430000" cy="360000"/>
-          </a:xfrm>
-          <a:prstGeom prst="rect">
-            <a:avLst/>
-          </a:prstGeom>
-          <a:noFill/>
-        </p:spPr>
-        <p:txBody>
-          <a:bodyPr wrap="square" anchor="t"/>
-          <a:lstStyle/>
-          <a:p>
-            <a:pPr algn="l"/>
-            <a:r>
-              <a:rPr lang="es-BO" sz="2300" dirty="0">
+            <a:off x="1080000" y="3260000"/>
+            <a:ext cx="4430000" cy="340000"/>
+          </a:xfrm>
+          <a:prstGeom prst="rect">
+            <a:avLst/>
+          </a:prstGeom>
+          <a:noFill/>
+        </p:spPr>
+        <p:txBody>
+          <a:bodyPr wrap="square" anchor="t"/>
+          <a:lstStyle/>
+          <a:p>
+            <a:pPr algn="l"/>
+            <a:r>
+              <a:rPr lang="es-BO" sz="2200" dirty="0">
                 <a:b/>
                 <a:solidFill>
                   <a:srgbClr val="1B7F5C"/>
@@ -3036,7 +3036,7 @@
         </p:nvSpPr>
         <p:spPr>
           <a:xfrm>
-            <a:off x="1120000" y="3512000"/>
+            <a:off x="1120000" y="3802000"/>
             <a:ext cx="95000" cy="95000"/>
           </a:xfrm>
           <a:prstGeom prst="ellipse">
@@ -3063,7 +3063,7 @@
         </p:nvSpPr>
         <p:spPr>
           <a:xfrm>
-            <a:off x="1275000" y="3460000"/>
+            <a:off x="1275000" y="3750000"/>
             <a:ext cx="4215000" cy="260000"/>
           </a:xfrm>
           <a:prstGeom prst="rect">
@@ -3096,7 +3096,7 @@
         </p:nvSpPr>
         <p:spPr>
           <a:xfrm>
-            <a:off x="1120000" y="3897000"/>
+            <a:off x="1120000" y="4187000"/>
             <a:ext cx="95000" cy="95000"/>
           </a:xfrm>
           <a:prstGeom prst="ellipse">
@@ -3123,7 +3123,7 @@
         </p:nvSpPr>
         <p:spPr>
           <a:xfrm>
-            <a:off x="1275000" y="3845000"/>
+            <a:off x="1275000" y="4135000"/>
             <a:ext cx="4215000" cy="260000"/>
           </a:xfrm>
           <a:prstGeom prst="rect">
@@ -3156,7 +3156,7 @@
         </p:nvSpPr>
         <p:spPr>
           <a:xfrm>
-            <a:off x="1120000" y="4282000"/>
+            <a:off x="1120000" y="4572000"/>
             <a:ext cx="95000" cy="95000"/>
           </a:xfrm>
           <a:prstGeom prst="ellipse">
@@ -3183,7 +3183,7 @@
         </p:nvSpPr>
         <p:spPr>
           <a:xfrm>
-            <a:off x="1275000" y="4230000"/>
+            <a:off x="1275000" y="4520000"/>
             <a:ext cx="4215000" cy="260000"/>
           </a:xfrm>
           <a:prstGeom prst="rect">
@@ -3216,7 +3216,7 @@
         </p:nvSpPr>
         <p:spPr>
           <a:xfrm>
-            <a:off x="1120000" y="4667000"/>
+            <a:off x="1120000" y="4957000"/>
             <a:ext cx="95000" cy="95000"/>
           </a:xfrm>
           <a:prstGeom prst="ellipse">
@@ -3243,7 +3243,7 @@
         </p:nvSpPr>
         <p:spPr>
           <a:xfrm>
-            <a:off x="1275000" y="4615000"/>
+            <a:off x="1275000" y="4905000"/>
             <a:ext cx="4215000" cy="260000"/>
           </a:xfrm>
           <a:prstGeom prst="rect">
@@ -3276,8 +3276,8 @@
         </p:nvSpPr>
         <p:spPr>
           <a:xfrm>
-            <a:off x="6110000" y="2680000"/>
-            <a:ext cx="4950000" cy="3520000"/>
+            <a:off x="6110000" y="3030000"/>
+            <a:ext cx="4950000" cy="3220000"/>
           </a:xfrm>
           <a:prstGeom prst="roundRect">
             <a:avLst/>
@@ -3305,21 +3305,21 @@
         </p:nvSpPr>
         <p:spPr>
           <a:xfrm>
-            <a:off x="6370000" y="2930000"/>
-            <a:ext cx="4430000" cy="360000"/>
-          </a:xfrm>
-          <a:prstGeom prst="rect">
-            <a:avLst/>
-          </a:prstGeom>
-          <a:noFill/>
-        </p:spPr>
-        <p:txBody>
-          <a:bodyPr wrap="square" anchor="t"/>
-          <a:lstStyle/>
-          <a:p>
-            <a:pPr algn="l"/>
-            <a:r>
-              <a:rPr lang="es-BO" sz="2300" dirty="0">
+            <a:off x="6370000" y="3260000"/>
+            <a:ext cx="4430000" cy="340000"/>
+          </a:xfrm>
+          <a:prstGeom prst="rect">
+            <a:avLst/>
+          </a:prstGeom>
+          <a:noFill/>
+        </p:spPr>
+        <p:txBody>
+          <a:bodyPr wrap="square" anchor="t"/>
+          <a:lstStyle/>
+          <a:p>
+            <a:pPr algn="l"/>
+            <a:r>
+              <a:rPr lang="es-BO" sz="2200" dirty="0">
                 <a:b/>
                 <a:solidFill>
                   <a:srgbClr val="1B7F5C"/>
@@ -3339,7 +3339,7 @@
         </p:nvSpPr>
         <p:spPr>
           <a:xfrm>
-            <a:off x="6410000" y="3512000"/>
+            <a:off x="6410000" y="3802000"/>
             <a:ext cx="95000" cy="95000"/>
           </a:xfrm>
           <a:prstGeom prst="ellipse">
@@ -3366,7 +3366,7 @@
         </p:nvSpPr>
         <p:spPr>
           <a:xfrm>
-            <a:off x="6565000" y="3460000"/>
+            <a:off x="6565000" y="3750000"/>
             <a:ext cx="4215000" cy="260000"/>
           </a:xfrm>
           <a:prstGeom prst="rect">
@@ -3399,7 +3399,7 @@
         </p:nvSpPr>
         <p:spPr>
           <a:xfrm>
-            <a:off x="6410000" y="3897000"/>
+            <a:off x="6410000" y="4187000"/>
             <a:ext cx="95000" cy="95000"/>
           </a:xfrm>
           <a:prstGeom prst="ellipse">
@@ -3426,7 +3426,7 @@
         </p:nvSpPr>
         <p:spPr>
           <a:xfrm>
-            <a:off x="6565000" y="3845000"/>
+            <a:off x="6565000" y="4135000"/>
             <a:ext cx="4215000" cy="260000"/>
           </a:xfrm>
           <a:prstGeom prst="rect">
@@ -3459,7 +3459,7 @@
         </p:nvSpPr>
         <p:spPr>
           <a:xfrm>
-            <a:off x="6410000" y="4282000"/>
+            <a:off x="6410000" y="4572000"/>
             <a:ext cx="95000" cy="95000"/>
           </a:xfrm>
           <a:prstGeom prst="ellipse">
@@ -3486,7 +3486,7 @@
         </p:nvSpPr>
         <p:spPr>
           <a:xfrm>
-            <a:off x="6565000" y="4230000"/>
+            <a:off x="6565000" y="4520000"/>
             <a:ext cx="4215000" cy="260000"/>
           </a:xfrm>
           <a:prstGeom prst="rect">
@@ -3519,7 +3519,7 @@
         </p:nvSpPr>
         <p:spPr>
           <a:xfrm>
-            <a:off x="6410000" y="4667000"/>
+            <a:off x="6410000" y="4957000"/>
             <a:ext cx="95000" cy="95000"/>
           </a:xfrm>
           <a:prstGeom prst="ellipse">
@@ -3546,7 +3546,7 @@
         </p:nvSpPr>
         <p:spPr>
           <a:xfrm>
-            <a:off x="6565000" y="4615000"/>
+            <a:off x="6565000" y="4905000"/>
             <a:ext cx="4215000" cy="260000"/>
           </a:xfrm>
           <a:prstGeom prst="rect">
@@ -3726,21 +3726,21 @@
         </p:nvSpPr>
         <p:spPr>
           <a:xfrm>
-            <a:off x="620000" y="775000"/>
-            <a:ext cx="7700000" cy="980000"/>
-          </a:xfrm>
-          <a:prstGeom prst="rect">
-            <a:avLst/>
-          </a:prstGeom>
-          <a:noFill/>
-        </p:spPr>
-        <p:txBody>
-          <a:bodyPr wrap="square" anchor="t"/>
-          <a:lstStyle/>
-          <a:p>
-            <a:pPr algn="l"/>
-            <a:r>
-              <a:rPr lang="es-BO" sz="4050" dirty="0">
+            <a:off x="620000" y="760000"/>
+            <a:ext cx="8250000" cy="1260000"/>
+          </a:xfrm>
+          <a:prstGeom prst="rect">
+            <a:avLst/>
+          </a:prstGeom>
+          <a:noFill/>
+        </p:spPr>
+        <p:txBody>
+          <a:bodyPr wrap="square" anchor="t"/>
+          <a:lstStyle/>
+          <a:p>
+            <a:pPr algn="l"/>
+            <a:r>
+              <a:rPr lang="es-BO" sz="3450" dirty="0">
                 <a:b/>
                 <a:solidFill>
                   <a:srgbClr val="12372A"/>
@@ -3760,441 +3760,441 @@
         </p:nvSpPr>
         <p:spPr>
           <a:xfrm>
-            <a:off x="630000" y="1710000"/>
-            <a:ext cx="7850000" cy="570000"/>
-          </a:xfrm>
-          <a:prstGeom prst="rect">
-            <a:avLst/>
-          </a:prstGeom>
-          <a:noFill/>
-        </p:spPr>
-        <p:txBody>
-          <a:bodyPr wrap="square" anchor="t"/>
-          <a:lstStyle/>
-          <a:p>
-            <a:pPr algn="l"/>
+            <a:off x="630000" y="2140000"/>
+            <a:ext cx="8350000" cy="620000"/>
+          </a:xfrm>
+          <a:prstGeom prst="rect">
+            <a:avLst/>
+          </a:prstGeom>
+          <a:noFill/>
+        </p:spPr>
+        <p:txBody>
+          <a:bodyPr wrap="square" anchor="t"/>
+          <a:lstStyle/>
+          <a:p>
+            <a:pPr algn="l"/>
+            <a:r>
+              <a:rPr lang="es-BO" sz="1850" dirty="0">
+                <a:solidFill>
+                  <a:srgbClr val="56635C"/>
+                </a:solidFill>
+                <a:latin typeface="Aptos"/>
+              </a:rPr>
+              <a:t>Una plataforma que recolecta, deduplica, prioriza y resume noticias locales con IA eficiente.</a:t>
+            </a:r>
+          </a:p>
+        </p:txBody>
+      </p:sp>
+      <p:sp>
+        <p:nvSpPr>
+          <p:cNvPr id="16" name="Shape"/>
+          <p:cNvSpPr/>
+          <p:nvPr/>
+        </p:nvSpPr>
+        <p:spPr>
+          <a:xfrm>
+            <a:off x="770000" y="3082000"/>
+            <a:ext cx="95000" cy="95000"/>
+          </a:xfrm>
+          <a:prstGeom prst="ellipse">
+            <a:avLst/>
+          </a:prstGeom>
+          <a:solidFill>
+            <a:srgbClr val="1B7F5C"/>
+          </a:solidFill>
+          <a:ln>
+            <a:noFill/>
+          </a:ln>
+        </p:spPr>
+        <p:txBody>
+          <a:bodyPr/>
+          <a:lstStyle/>
+          <a:p/>
+        </p:txBody>
+      </p:sp>
+      <p:sp>
+        <p:nvSpPr>
+          <p:cNvPr id="17" name="Text"/>
+          <p:cNvSpPr txBox="1"/>
+          <p:nvPr/>
+        </p:nvSpPr>
+        <p:spPr>
+          <a:xfrm>
+            <a:off x="925000" y="3030000"/>
+            <a:ext cx="6695000" cy="260000"/>
+          </a:xfrm>
+          <a:prstGeom prst="rect">
+            <a:avLst/>
+          </a:prstGeom>
+          <a:noFill/>
+        </p:spPr>
+        <p:txBody>
+          <a:bodyPr wrap="square" anchor="t"/>
+          <a:lstStyle/>
+          <a:p>
+            <a:pPr algn="l"/>
+            <a:r>
+              <a:rPr lang="es-BO" sz="2150" dirty="0">
+                <a:solidFill>
+                  <a:srgbClr val="17211B"/>
+                </a:solidFill>
+                <a:latin typeface="Aptos"/>
+              </a:rPr>
+              <a:t>Recolecta noticias de medios bolivianos.</a:t>
+            </a:r>
+          </a:p>
+        </p:txBody>
+      </p:sp>
+      <p:sp>
+        <p:nvSpPr>
+          <p:cNvPr id="18" name="Shape"/>
+          <p:cNvSpPr/>
+          <p:nvPr/>
+        </p:nvSpPr>
+        <p:spPr>
+          <a:xfrm>
+            <a:off x="770000" y="3467000"/>
+            <a:ext cx="95000" cy="95000"/>
+          </a:xfrm>
+          <a:prstGeom prst="ellipse">
+            <a:avLst/>
+          </a:prstGeom>
+          <a:solidFill>
+            <a:srgbClr val="1B7F5C"/>
+          </a:solidFill>
+          <a:ln>
+            <a:noFill/>
+          </a:ln>
+        </p:spPr>
+        <p:txBody>
+          <a:bodyPr/>
+          <a:lstStyle/>
+          <a:p/>
+        </p:txBody>
+      </p:sp>
+      <p:sp>
+        <p:nvSpPr>
+          <p:cNvPr id="19" name="Text"/>
+          <p:cNvSpPr txBox="1"/>
+          <p:nvPr/>
+        </p:nvSpPr>
+        <p:spPr>
+          <a:xfrm>
+            <a:off x="925000" y="3415000"/>
+            <a:ext cx="6695000" cy="260000"/>
+          </a:xfrm>
+          <a:prstGeom prst="rect">
+            <a:avLst/>
+          </a:prstGeom>
+          <a:noFill/>
+        </p:spPr>
+        <p:txBody>
+          <a:bodyPr wrap="square" anchor="t"/>
+          <a:lstStyle/>
+          <a:p>
+            <a:pPr algn="l"/>
+            <a:r>
+              <a:rPr lang="es-BO" sz="2150" dirty="0">
+                <a:solidFill>
+                  <a:srgbClr val="17211B"/>
+                </a:solidFill>
+                <a:latin typeface="Aptos"/>
+              </a:rPr>
+              <a:t>Extrae titulo, descripcion, cuerpo, fecha, fuente e imagen.</a:t>
+            </a:r>
+          </a:p>
+        </p:txBody>
+      </p:sp>
+      <p:sp>
+        <p:nvSpPr>
+          <p:cNvPr id="20" name="Shape"/>
+          <p:cNvSpPr/>
+          <p:nvPr/>
+        </p:nvSpPr>
+        <p:spPr>
+          <a:xfrm>
+            <a:off x="770000" y="3852000"/>
+            <a:ext cx="95000" cy="95000"/>
+          </a:xfrm>
+          <a:prstGeom prst="ellipse">
+            <a:avLst/>
+          </a:prstGeom>
+          <a:solidFill>
+            <a:srgbClr val="1B7F5C"/>
+          </a:solidFill>
+          <a:ln>
+            <a:noFill/>
+          </a:ln>
+        </p:spPr>
+        <p:txBody>
+          <a:bodyPr/>
+          <a:lstStyle/>
+          <a:p/>
+        </p:txBody>
+      </p:sp>
+      <p:sp>
+        <p:nvSpPr>
+          <p:cNvPr id="21" name="Text"/>
+          <p:cNvSpPr txBox="1"/>
+          <p:nvPr/>
+        </p:nvSpPr>
+        <p:spPr>
+          <a:xfrm>
+            <a:off x="925000" y="3800000"/>
+            <a:ext cx="6695000" cy="260000"/>
+          </a:xfrm>
+          <a:prstGeom prst="rect">
+            <a:avLst/>
+          </a:prstGeom>
+          <a:noFill/>
+        </p:spPr>
+        <p:txBody>
+          <a:bodyPr wrap="square" anchor="t"/>
+          <a:lstStyle/>
+          <a:p>
+            <a:pPr algn="l"/>
+            <a:r>
+              <a:rPr lang="es-BO" sz="2150" dirty="0">
+                <a:solidFill>
+                  <a:srgbClr val="17211B"/>
+                </a:solidFill>
+                <a:latin typeface="Aptos"/>
+              </a:rPr>
+              <a:t>Elimina duplicados y agrupa historias.</a:t>
+            </a:r>
+          </a:p>
+        </p:txBody>
+      </p:sp>
+      <p:sp>
+        <p:nvSpPr>
+          <p:cNvPr id="22" name="Shape"/>
+          <p:cNvSpPr/>
+          <p:nvPr/>
+        </p:nvSpPr>
+        <p:spPr>
+          <a:xfrm>
+            <a:off x="770000" y="4237000"/>
+            <a:ext cx="95000" cy="95000"/>
+          </a:xfrm>
+          <a:prstGeom prst="ellipse">
+            <a:avLst/>
+          </a:prstGeom>
+          <a:solidFill>
+            <a:srgbClr val="1B7F5C"/>
+          </a:solidFill>
+          <a:ln>
+            <a:noFill/>
+          </a:ln>
+        </p:spPr>
+        <p:txBody>
+          <a:bodyPr/>
+          <a:lstStyle/>
+          <a:p/>
+        </p:txBody>
+      </p:sp>
+      <p:sp>
+        <p:nvSpPr>
+          <p:cNvPr id="23" name="Text"/>
+          <p:cNvSpPr txBox="1"/>
+          <p:nvPr/>
+        </p:nvSpPr>
+        <p:spPr>
+          <a:xfrm>
+            <a:off x="925000" y="4185000"/>
+            <a:ext cx="6695000" cy="260000"/>
+          </a:xfrm>
+          <a:prstGeom prst="rect">
+            <a:avLst/>
+          </a:prstGeom>
+          <a:noFill/>
+        </p:spPr>
+        <p:txBody>
+          <a:bodyPr wrap="square" anchor="t"/>
+          <a:lstStyle/>
+          <a:p>
+            <a:pPr algn="l"/>
+            <a:r>
+              <a:rPr lang="es-BO" sz="2150" dirty="0">
+                <a:solidFill>
+                  <a:srgbClr val="17211B"/>
+                </a:solidFill>
+                <a:latin typeface="Aptos"/>
+              </a:rPr>
+              <a:t>Resume solo los articulos seleccionados.</a:t>
+            </a:r>
+          </a:p>
+        </p:txBody>
+      </p:sp>
+      <p:sp>
+        <p:nvSpPr>
+          <p:cNvPr id="24" name="Shape"/>
+          <p:cNvSpPr/>
+          <p:nvPr/>
+        </p:nvSpPr>
+        <p:spPr>
+          <a:xfrm>
+            <a:off x="770000" y="4622000"/>
+            <a:ext cx="95000" cy="95000"/>
+          </a:xfrm>
+          <a:prstGeom prst="ellipse">
+            <a:avLst/>
+          </a:prstGeom>
+          <a:solidFill>
+            <a:srgbClr val="1B7F5C"/>
+          </a:solidFill>
+          <a:ln>
+            <a:noFill/>
+          </a:ln>
+        </p:spPr>
+        <p:txBody>
+          <a:bodyPr/>
+          <a:lstStyle/>
+          <a:p/>
+        </p:txBody>
+      </p:sp>
+      <p:sp>
+        <p:nvSpPr>
+          <p:cNvPr id="25" name="Text"/>
+          <p:cNvSpPr txBox="1"/>
+          <p:nvPr/>
+        </p:nvSpPr>
+        <p:spPr>
+          <a:xfrm>
+            <a:off x="925000" y="4570000"/>
+            <a:ext cx="6695000" cy="260000"/>
+          </a:xfrm>
+          <a:prstGeom prst="rect">
+            <a:avLst/>
+          </a:prstGeom>
+          <a:noFill/>
+        </p:spPr>
+        <p:txBody>
+          <a:bodyPr wrap="square" anchor="t"/>
+          <a:lstStyle/>
+          <a:p>
+            <a:pPr algn="l"/>
+            <a:r>
+              <a:rPr lang="es-BO" sz="2150" dirty="0">
+                <a:solidFill>
+                  <a:srgbClr val="17211B"/>
+                </a:solidFill>
+                <a:latin typeface="Aptos"/>
+              </a:rPr>
+              <a:t>Mantiene enlace a fuentes originales identificadas.</a:t>
+            </a:r>
+          </a:p>
+        </p:txBody>
+      </p:sp>
+      <p:sp>
+        <p:nvSpPr>
+          <p:cNvPr id="26" name="Shape"/>
+          <p:cNvSpPr/>
+          <p:nvPr/>
+        </p:nvSpPr>
+        <p:spPr>
+          <a:xfrm>
+            <a:off x="770000" y="5007000"/>
+            <a:ext cx="95000" cy="95000"/>
+          </a:xfrm>
+          <a:prstGeom prst="ellipse">
+            <a:avLst/>
+          </a:prstGeom>
+          <a:solidFill>
+            <a:srgbClr val="1B7F5C"/>
+          </a:solidFill>
+          <a:ln>
+            <a:noFill/>
+          </a:ln>
+        </p:spPr>
+        <p:txBody>
+          <a:bodyPr/>
+          <a:lstStyle/>
+          <a:p/>
+        </p:txBody>
+      </p:sp>
+      <p:sp>
+        <p:nvSpPr>
+          <p:cNvPr id="27" name="Text"/>
+          <p:cNvSpPr txBox="1"/>
+          <p:nvPr/>
+        </p:nvSpPr>
+        <p:spPr>
+          <a:xfrm>
+            <a:off x="925000" y="4955000"/>
+            <a:ext cx="6695000" cy="260000"/>
+          </a:xfrm>
+          <a:prstGeom prst="rect">
+            <a:avLst/>
+          </a:prstGeom>
+          <a:noFill/>
+        </p:spPr>
+        <p:txBody>
+          <a:bodyPr wrap="square" anchor="t"/>
+          <a:lstStyle/>
+          <a:p>
+            <a:pPr algn="l"/>
+            <a:r>
+              <a:rPr lang="es-BO" sz="2150" dirty="0">
+                <a:solidFill>
+                  <a:srgbClr val="17211B"/>
+                </a:solidFill>
+                <a:latin typeface="Aptos"/>
+              </a:rPr>
+              <a:t>Entrega briefs por web y prepara distribucion personalizada.</a:t>
+            </a:r>
+          </a:p>
+        </p:txBody>
+      </p:sp>
+      <p:sp>
+        <p:nvSpPr>
+          <p:cNvPr id="28" name="Shape"/>
+          <p:cNvSpPr/>
+          <p:nvPr/>
+        </p:nvSpPr>
+        <p:spPr>
+          <a:xfrm>
+            <a:off x="8500000" y="5140000"/>
+            <a:ext cx="3900000" cy="1150000"/>
+          </a:xfrm>
+          <a:prstGeom prst="roundRect">
+            <a:avLst/>
+          </a:prstGeom>
+          <a:solidFill>
+            <a:srgbClr val="12372A"/>
+          </a:solidFill>
+          <a:ln>
+            <a:noFill/>
+          </a:ln>
+        </p:spPr>
+        <p:txBody>
+          <a:bodyPr/>
+          <a:lstStyle/>
+          <a:p/>
+        </p:txBody>
+      </p:sp>
+      <p:sp>
+        <p:nvSpPr>
+          <p:cNvPr id="29" name="Text"/>
+          <p:cNvSpPr txBox="1"/>
+          <p:nvPr/>
+        </p:nvSpPr>
+        <p:spPr>
+          <a:xfrm>
+            <a:off x="8790000" y="5400000"/>
+            <a:ext cx="3320000" cy="540000"/>
+          </a:xfrm>
+          <a:prstGeom prst="rect">
+            <a:avLst/>
+          </a:prstGeom>
+          <a:noFill/>
+        </p:spPr>
+        <p:txBody>
+          <a:bodyPr wrap="square" anchor="t"/>
+          <a:lstStyle/>
+          <a:p>
+            <a:pPr algn="c"/>
             <a:r>
               <a:rPr lang="es-BO" sz="1950" dirty="0">
-                <a:solidFill>
-                  <a:srgbClr val="56635C"/>
-                </a:solidFill>
-                <a:latin typeface="Aptos"/>
-              </a:rPr>
-              <a:t>Una plataforma que recolecta, deduplica, prioriza y resume noticias locales con IA eficiente.</a:t>
-            </a:r>
-          </a:p>
-        </p:txBody>
-      </p:sp>
-      <p:sp>
-        <p:nvSpPr>
-          <p:cNvPr id="16" name="Shape"/>
-          <p:cNvSpPr/>
-          <p:nvPr/>
-        </p:nvSpPr>
-        <p:spPr>
-          <a:xfrm>
-            <a:off x="770000" y="2702000"/>
-            <a:ext cx="95000" cy="95000"/>
-          </a:xfrm>
-          <a:prstGeom prst="ellipse">
-            <a:avLst/>
-          </a:prstGeom>
-          <a:solidFill>
-            <a:srgbClr val="1B7F5C"/>
-          </a:solidFill>
-          <a:ln>
-            <a:noFill/>
-          </a:ln>
-        </p:spPr>
-        <p:txBody>
-          <a:bodyPr/>
-          <a:lstStyle/>
-          <a:p/>
-        </p:txBody>
-      </p:sp>
-      <p:sp>
-        <p:nvSpPr>
-          <p:cNvPr id="17" name="Text"/>
-          <p:cNvSpPr txBox="1"/>
-          <p:nvPr/>
-        </p:nvSpPr>
-        <p:spPr>
-          <a:xfrm>
-            <a:off x="925000" y="2650000"/>
-            <a:ext cx="6695000" cy="260000"/>
-          </a:xfrm>
-          <a:prstGeom prst="rect">
-            <a:avLst/>
-          </a:prstGeom>
-          <a:noFill/>
-        </p:spPr>
-        <p:txBody>
-          <a:bodyPr wrap="square" anchor="t"/>
-          <a:lstStyle/>
-          <a:p>
-            <a:pPr algn="l"/>
-            <a:r>
-              <a:rPr lang="es-BO" sz="2150" dirty="0">
-                <a:solidFill>
-                  <a:srgbClr val="17211B"/>
-                </a:solidFill>
-                <a:latin typeface="Aptos"/>
-              </a:rPr>
-              <a:t>Recolecta noticias de medios bolivianos.</a:t>
-            </a:r>
-          </a:p>
-        </p:txBody>
-      </p:sp>
-      <p:sp>
-        <p:nvSpPr>
-          <p:cNvPr id="18" name="Shape"/>
-          <p:cNvSpPr/>
-          <p:nvPr/>
-        </p:nvSpPr>
-        <p:spPr>
-          <a:xfrm>
-            <a:off x="770000" y="3087000"/>
-            <a:ext cx="95000" cy="95000"/>
-          </a:xfrm>
-          <a:prstGeom prst="ellipse">
-            <a:avLst/>
-          </a:prstGeom>
-          <a:solidFill>
-            <a:srgbClr val="1B7F5C"/>
-          </a:solidFill>
-          <a:ln>
-            <a:noFill/>
-          </a:ln>
-        </p:spPr>
-        <p:txBody>
-          <a:bodyPr/>
-          <a:lstStyle/>
-          <a:p/>
-        </p:txBody>
-      </p:sp>
-      <p:sp>
-        <p:nvSpPr>
-          <p:cNvPr id="19" name="Text"/>
-          <p:cNvSpPr txBox="1"/>
-          <p:nvPr/>
-        </p:nvSpPr>
-        <p:spPr>
-          <a:xfrm>
-            <a:off x="925000" y="3035000"/>
-            <a:ext cx="6695000" cy="260000"/>
-          </a:xfrm>
-          <a:prstGeom prst="rect">
-            <a:avLst/>
-          </a:prstGeom>
-          <a:noFill/>
-        </p:spPr>
-        <p:txBody>
-          <a:bodyPr wrap="square" anchor="t"/>
-          <a:lstStyle/>
-          <a:p>
-            <a:pPr algn="l"/>
-            <a:r>
-              <a:rPr lang="es-BO" sz="2150" dirty="0">
-                <a:solidFill>
-                  <a:srgbClr val="17211B"/>
-                </a:solidFill>
-                <a:latin typeface="Aptos"/>
-              </a:rPr>
-              <a:t>Extrae titulo, descripcion, cuerpo, fecha, fuente e imagen.</a:t>
-            </a:r>
-          </a:p>
-        </p:txBody>
-      </p:sp>
-      <p:sp>
-        <p:nvSpPr>
-          <p:cNvPr id="20" name="Shape"/>
-          <p:cNvSpPr/>
-          <p:nvPr/>
-        </p:nvSpPr>
-        <p:spPr>
-          <a:xfrm>
-            <a:off x="770000" y="3472000"/>
-            <a:ext cx="95000" cy="95000"/>
-          </a:xfrm>
-          <a:prstGeom prst="ellipse">
-            <a:avLst/>
-          </a:prstGeom>
-          <a:solidFill>
-            <a:srgbClr val="1B7F5C"/>
-          </a:solidFill>
-          <a:ln>
-            <a:noFill/>
-          </a:ln>
-        </p:spPr>
-        <p:txBody>
-          <a:bodyPr/>
-          <a:lstStyle/>
-          <a:p/>
-        </p:txBody>
-      </p:sp>
-      <p:sp>
-        <p:nvSpPr>
-          <p:cNvPr id="21" name="Text"/>
-          <p:cNvSpPr txBox="1"/>
-          <p:nvPr/>
-        </p:nvSpPr>
-        <p:spPr>
-          <a:xfrm>
-            <a:off x="925000" y="3420000"/>
-            <a:ext cx="6695000" cy="260000"/>
-          </a:xfrm>
-          <a:prstGeom prst="rect">
-            <a:avLst/>
-          </a:prstGeom>
-          <a:noFill/>
-        </p:spPr>
-        <p:txBody>
-          <a:bodyPr wrap="square" anchor="t"/>
-          <a:lstStyle/>
-          <a:p>
-            <a:pPr algn="l"/>
-            <a:r>
-              <a:rPr lang="es-BO" sz="2150" dirty="0">
-                <a:solidFill>
-                  <a:srgbClr val="17211B"/>
-                </a:solidFill>
-                <a:latin typeface="Aptos"/>
-              </a:rPr>
-              <a:t>Elimina duplicados y agrupa historias.</a:t>
-            </a:r>
-          </a:p>
-        </p:txBody>
-      </p:sp>
-      <p:sp>
-        <p:nvSpPr>
-          <p:cNvPr id="22" name="Shape"/>
-          <p:cNvSpPr/>
-          <p:nvPr/>
-        </p:nvSpPr>
-        <p:spPr>
-          <a:xfrm>
-            <a:off x="770000" y="3857000"/>
-            <a:ext cx="95000" cy="95000"/>
-          </a:xfrm>
-          <a:prstGeom prst="ellipse">
-            <a:avLst/>
-          </a:prstGeom>
-          <a:solidFill>
-            <a:srgbClr val="1B7F5C"/>
-          </a:solidFill>
-          <a:ln>
-            <a:noFill/>
-          </a:ln>
-        </p:spPr>
-        <p:txBody>
-          <a:bodyPr/>
-          <a:lstStyle/>
-          <a:p/>
-        </p:txBody>
-      </p:sp>
-      <p:sp>
-        <p:nvSpPr>
-          <p:cNvPr id="23" name="Text"/>
-          <p:cNvSpPr txBox="1"/>
-          <p:nvPr/>
-        </p:nvSpPr>
-        <p:spPr>
-          <a:xfrm>
-            <a:off x="925000" y="3805000"/>
-            <a:ext cx="6695000" cy="260000"/>
-          </a:xfrm>
-          <a:prstGeom prst="rect">
-            <a:avLst/>
-          </a:prstGeom>
-          <a:noFill/>
-        </p:spPr>
-        <p:txBody>
-          <a:bodyPr wrap="square" anchor="t"/>
-          <a:lstStyle/>
-          <a:p>
-            <a:pPr algn="l"/>
-            <a:r>
-              <a:rPr lang="es-BO" sz="2150" dirty="0">
-                <a:solidFill>
-                  <a:srgbClr val="17211B"/>
-                </a:solidFill>
-                <a:latin typeface="Aptos"/>
-              </a:rPr>
-              <a:t>Resume solo los articulos seleccionados.</a:t>
-            </a:r>
-          </a:p>
-        </p:txBody>
-      </p:sp>
-      <p:sp>
-        <p:nvSpPr>
-          <p:cNvPr id="24" name="Shape"/>
-          <p:cNvSpPr/>
-          <p:nvPr/>
-        </p:nvSpPr>
-        <p:spPr>
-          <a:xfrm>
-            <a:off x="770000" y="4242000"/>
-            <a:ext cx="95000" cy="95000"/>
-          </a:xfrm>
-          <a:prstGeom prst="ellipse">
-            <a:avLst/>
-          </a:prstGeom>
-          <a:solidFill>
-            <a:srgbClr val="1B7F5C"/>
-          </a:solidFill>
-          <a:ln>
-            <a:noFill/>
-          </a:ln>
-        </p:spPr>
-        <p:txBody>
-          <a:bodyPr/>
-          <a:lstStyle/>
-          <a:p/>
-        </p:txBody>
-      </p:sp>
-      <p:sp>
-        <p:nvSpPr>
-          <p:cNvPr id="25" name="Text"/>
-          <p:cNvSpPr txBox="1"/>
-          <p:nvPr/>
-        </p:nvSpPr>
-        <p:spPr>
-          <a:xfrm>
-            <a:off x="925000" y="4190000"/>
-            <a:ext cx="6695000" cy="260000"/>
-          </a:xfrm>
-          <a:prstGeom prst="rect">
-            <a:avLst/>
-          </a:prstGeom>
-          <a:noFill/>
-        </p:spPr>
-        <p:txBody>
-          <a:bodyPr wrap="square" anchor="t"/>
-          <a:lstStyle/>
-          <a:p>
-            <a:pPr algn="l"/>
-            <a:r>
-              <a:rPr lang="es-BO" sz="2150" dirty="0">
-                <a:solidFill>
-                  <a:srgbClr val="17211B"/>
-                </a:solidFill>
-                <a:latin typeface="Aptos"/>
-              </a:rPr>
-              <a:t>Mantiene enlace a fuentes originales identificadas.</a:t>
-            </a:r>
-          </a:p>
-        </p:txBody>
-      </p:sp>
-      <p:sp>
-        <p:nvSpPr>
-          <p:cNvPr id="26" name="Shape"/>
-          <p:cNvSpPr/>
-          <p:nvPr/>
-        </p:nvSpPr>
-        <p:spPr>
-          <a:xfrm>
-            <a:off x="770000" y="4627000"/>
-            <a:ext cx="95000" cy="95000"/>
-          </a:xfrm>
-          <a:prstGeom prst="ellipse">
-            <a:avLst/>
-          </a:prstGeom>
-          <a:solidFill>
-            <a:srgbClr val="1B7F5C"/>
-          </a:solidFill>
-          <a:ln>
-            <a:noFill/>
-          </a:ln>
-        </p:spPr>
-        <p:txBody>
-          <a:bodyPr/>
-          <a:lstStyle/>
-          <a:p/>
-        </p:txBody>
-      </p:sp>
-      <p:sp>
-        <p:nvSpPr>
-          <p:cNvPr id="27" name="Text"/>
-          <p:cNvSpPr txBox="1"/>
-          <p:nvPr/>
-        </p:nvSpPr>
-        <p:spPr>
-          <a:xfrm>
-            <a:off x="925000" y="4575000"/>
-            <a:ext cx="6695000" cy="260000"/>
-          </a:xfrm>
-          <a:prstGeom prst="rect">
-            <a:avLst/>
-          </a:prstGeom>
-          <a:noFill/>
-        </p:spPr>
-        <p:txBody>
-          <a:bodyPr wrap="square" anchor="t"/>
-          <a:lstStyle/>
-          <a:p>
-            <a:pPr algn="l"/>
-            <a:r>
-              <a:rPr lang="es-BO" sz="2150" dirty="0">
-                <a:solidFill>
-                  <a:srgbClr val="17211B"/>
-                </a:solidFill>
-                <a:latin typeface="Aptos"/>
-              </a:rPr>
-              <a:t>Entrega briefs por web y prepara distribucion personalizada.</a:t>
-            </a:r>
-          </a:p>
-        </p:txBody>
-      </p:sp>
-      <p:sp>
-        <p:nvSpPr>
-          <p:cNvPr id="28" name="Shape"/>
-          <p:cNvSpPr/>
-          <p:nvPr/>
-        </p:nvSpPr>
-        <p:spPr>
-          <a:xfrm>
-            <a:off x="8500000" y="4920000"/>
-            <a:ext cx="3900000" cy="1150000"/>
-          </a:xfrm>
-          <a:prstGeom prst="roundRect">
-            <a:avLst/>
-          </a:prstGeom>
-          <a:solidFill>
-            <a:srgbClr val="12372A"/>
-          </a:solidFill>
-          <a:ln>
-            <a:noFill/>
-          </a:ln>
-        </p:spPr>
-        <p:txBody>
-          <a:bodyPr/>
-          <a:lstStyle/>
-          <a:p/>
-        </p:txBody>
-      </p:sp>
-      <p:sp>
-        <p:nvSpPr>
-          <p:cNvPr id="29" name="Text"/>
-          <p:cNvSpPr txBox="1"/>
-          <p:nvPr/>
-        </p:nvSpPr>
-        <p:spPr>
-          <a:xfrm>
-            <a:off x="8790000" y="5180000"/>
-            <a:ext cx="3320000" cy="540000"/>
-          </a:xfrm>
-          <a:prstGeom prst="rect">
-            <a:avLst/>
-          </a:prstGeom>
-          <a:noFill/>
-        </p:spPr>
-        <p:txBody>
-          <a:bodyPr wrap="square" anchor="t"/>
-          <a:lstStyle/>
-          <a:p>
-            <a:pPr algn="c"/>
-            <a:r>
-              <a:rPr lang="es-BO" sz="2050" dirty="0">
                 <a:b/>
                 <a:solidFill>
                   <a:srgbClr val="FFFFFF"/>
@@ -4361,21 +4361,21 @@
         </p:nvSpPr>
         <p:spPr>
           <a:xfrm>
-            <a:off x="620000" y="775000"/>
-            <a:ext cx="7700000" cy="980000"/>
-          </a:xfrm>
-          <a:prstGeom prst="rect">
-            <a:avLst/>
-          </a:prstGeom>
-          <a:noFill/>
-        </p:spPr>
-        <p:txBody>
-          <a:bodyPr wrap="square" anchor="t"/>
-          <a:lstStyle/>
-          <a:p>
-            <a:pPr algn="l"/>
-            <a:r>
-              <a:rPr lang="es-BO" sz="4050" dirty="0">
+            <a:off x="620000" y="760000"/>
+            <a:ext cx="8250000" cy="1260000"/>
+          </a:xfrm>
+          <a:prstGeom prst="rect">
+            <a:avLst/>
+          </a:prstGeom>
+          <a:noFill/>
+        </p:spPr>
+        <p:txBody>
+          <a:bodyPr wrap="square" anchor="t"/>
+          <a:lstStyle/>
+          <a:p>
+            <a:pPr algn="l"/>
+            <a:r>
+              <a:rPr lang="es-BO" sz="3450" dirty="0">
                 <a:b/>
                 <a:solidFill>
                   <a:srgbClr val="12372A"/>
@@ -4395,21 +4395,21 @@
         </p:nvSpPr>
         <p:spPr>
           <a:xfrm>
-            <a:off x="630000" y="1710000"/>
-            <a:ext cx="7850000" cy="570000"/>
-          </a:xfrm>
-          <a:prstGeom prst="rect">
-            <a:avLst/>
-          </a:prstGeom>
-          <a:noFill/>
-        </p:spPr>
-        <p:txBody>
-          <a:bodyPr wrap="square" anchor="t"/>
-          <a:lstStyle/>
-          <a:p>
-            <a:pPr algn="l"/>
-            <a:r>
-              <a:rPr lang="es-BO" sz="1950" dirty="0">
+            <a:off x="630000" y="2140000"/>
+            <a:ext cx="8350000" cy="620000"/>
+          </a:xfrm>
+          <a:prstGeom prst="rect">
+            <a:avLst/>
+          </a:prstGeom>
+          <a:noFill/>
+        </p:spPr>
+        <p:txBody>
+          <a:bodyPr wrap="square" anchor="t"/>
+          <a:lstStyle/>
+          <a:p>
+            <a:pPr algn="l"/>
+            <a:r>
+              <a:rPr lang="es-BO" sz="1850" dirty="0">
                 <a:solidFill>
                   <a:srgbClr val="56635C"/>
                 </a:solidFill>
@@ -4428,7 +4428,7 @@
         </p:nvSpPr>
         <p:spPr>
           <a:xfrm>
-            <a:off x="720000" y="3020000"/>
+            <a:off x="720000" y="3290000"/>
             <a:ext cx="1350000" cy="760000"/>
           </a:xfrm>
           <a:prstGeom prst="roundRect">
@@ -4457,7 +4457,7 @@
         </p:nvSpPr>
         <p:spPr>
           <a:xfrm>
-            <a:off x="800000" y="3155000"/>
+            <a:off x="800000" y="3425000"/>
             <a:ext cx="1190000" cy="180000"/>
           </a:xfrm>
           <a:prstGeom prst="rect">
@@ -4491,7 +4491,7 @@
         </p:nvSpPr>
         <p:spPr>
           <a:xfrm>
-            <a:off x="820000" y="3370000"/>
+            <a:off x="820000" y="3640000"/>
             <a:ext cx="1150000" cy="280000"/>
           </a:xfrm>
           <a:prstGeom prst="rect">
@@ -4525,7 +4525,7 @@
         </p:nvSpPr>
         <p:spPr>
           <a:xfrm>
-            <a:off x="2100000" y="3270000"/>
+            <a:off x="2100000" y="3540000"/>
             <a:ext cx="250000" cy="250000"/>
           </a:xfrm>
           <a:prstGeom prst="rect">
@@ -4559,7 +4559,7 @@
         </p:nvSpPr>
         <p:spPr>
           <a:xfrm>
-            <a:off x="2290000" y="3020000"/>
+            <a:off x="2290000" y="3290000"/>
             <a:ext cx="1350000" cy="760000"/>
           </a:xfrm>
           <a:prstGeom prst="roundRect">
@@ -4588,7 +4588,7 @@
         </p:nvSpPr>
         <p:spPr>
           <a:xfrm>
-            <a:off x="2370000" y="3155000"/>
+            <a:off x="2370000" y="3425000"/>
             <a:ext cx="1190000" cy="180000"/>
           </a:xfrm>
           <a:prstGeom prst="rect">
@@ -4622,7 +4622,7 @@
         </p:nvSpPr>
         <p:spPr>
           <a:xfrm>
-            <a:off x="2390000" y="3370000"/>
+            <a:off x="2390000" y="3640000"/>
             <a:ext cx="1150000" cy="280000"/>
           </a:xfrm>
           <a:prstGeom prst="rect">
@@ -4656,7 +4656,7 @@
         </p:nvSpPr>
         <p:spPr>
           <a:xfrm>
-            <a:off x="3670000" y="3270000"/>
+            <a:off x="3670000" y="3540000"/>
             <a:ext cx="250000" cy="250000"/>
           </a:xfrm>
           <a:prstGeom prst="rect">
@@ -4690,7 +4690,7 @@
         </p:nvSpPr>
         <p:spPr>
           <a:xfrm>
-            <a:off x="3860000" y="3020000"/>
+            <a:off x="3860000" y="3290000"/>
             <a:ext cx="1350000" cy="760000"/>
           </a:xfrm>
           <a:prstGeom prst="roundRect">
@@ -4719,7 +4719,7 @@
         </p:nvSpPr>
         <p:spPr>
           <a:xfrm>
-            <a:off x="3940000" y="3155000"/>
+            <a:off x="3940000" y="3425000"/>
             <a:ext cx="1190000" cy="180000"/>
           </a:xfrm>
           <a:prstGeom prst="rect">
@@ -4753,7 +4753,7 @@
         </p:nvSpPr>
         <p:spPr>
           <a:xfrm>
-            <a:off x="3960000" y="3370000"/>
+            <a:off x="3960000" y="3640000"/>
             <a:ext cx="1150000" cy="280000"/>
           </a:xfrm>
           <a:prstGeom prst="rect">
@@ -4787,7 +4787,7 @@
         </p:nvSpPr>
         <p:spPr>
           <a:xfrm>
-            <a:off x="5240000" y="3270000"/>
+            <a:off x="5240000" y="3540000"/>
             <a:ext cx="250000" cy="250000"/>
           </a:xfrm>
           <a:prstGeom prst="rect">
@@ -4821,7 +4821,7 @@
         </p:nvSpPr>
         <p:spPr>
           <a:xfrm>
-            <a:off x="5430000" y="3020000"/>
+            <a:off x="5430000" y="3290000"/>
             <a:ext cx="1350000" cy="760000"/>
           </a:xfrm>
           <a:prstGeom prst="roundRect">
@@ -4850,7 +4850,7 @@
         </p:nvSpPr>
         <p:spPr>
           <a:xfrm>
-            <a:off x="5510000" y="3155000"/>
+            <a:off x="5510000" y="3425000"/>
             <a:ext cx="1190000" cy="180000"/>
           </a:xfrm>
           <a:prstGeom prst="rect">
@@ -4884,7 +4884,7 @@
         </p:nvSpPr>
         <p:spPr>
           <a:xfrm>
-            <a:off x="5530000" y="3370000"/>
+            <a:off x="5530000" y="3640000"/>
             <a:ext cx="1150000" cy="280000"/>
           </a:xfrm>
           <a:prstGeom prst="rect">
@@ -4918,7 +4918,7 @@
         </p:nvSpPr>
         <p:spPr>
           <a:xfrm>
-            <a:off x="6810000" y="3270000"/>
+            <a:off x="6810000" y="3540000"/>
             <a:ext cx="250000" cy="250000"/>
           </a:xfrm>
           <a:prstGeom prst="rect">
@@ -4952,7 +4952,7 @@
         </p:nvSpPr>
         <p:spPr>
           <a:xfrm>
-            <a:off x="7000000" y="3020000"/>
+            <a:off x="7000000" y="3290000"/>
             <a:ext cx="1350000" cy="760000"/>
           </a:xfrm>
           <a:prstGeom prst="roundRect">
@@ -4981,7 +4981,7 @@
         </p:nvSpPr>
         <p:spPr>
           <a:xfrm>
-            <a:off x="7080000" y="3155000"/>
+            <a:off x="7080000" y="3425000"/>
             <a:ext cx="1190000" cy="180000"/>
           </a:xfrm>
           <a:prstGeom prst="rect">
@@ -5015,7 +5015,7 @@
         </p:nvSpPr>
         <p:spPr>
           <a:xfrm>
-            <a:off x="7100000" y="3370000"/>
+            <a:off x="7100000" y="3640000"/>
             <a:ext cx="1150000" cy="280000"/>
           </a:xfrm>
           <a:prstGeom prst="rect">
@@ -5049,7 +5049,7 @@
         </p:nvSpPr>
         <p:spPr>
           <a:xfrm>
-            <a:off x="8380000" y="3270000"/>
+            <a:off x="8380000" y="3540000"/>
             <a:ext cx="250000" cy="250000"/>
           </a:xfrm>
           <a:prstGeom prst="rect">
@@ -5083,7 +5083,7 @@
         </p:nvSpPr>
         <p:spPr>
           <a:xfrm>
-            <a:off x="8570000" y="3020000"/>
+            <a:off x="8570000" y="3290000"/>
             <a:ext cx="1350000" cy="760000"/>
           </a:xfrm>
           <a:prstGeom prst="roundRect">
@@ -5112,7 +5112,7 @@
         </p:nvSpPr>
         <p:spPr>
           <a:xfrm>
-            <a:off x="8650000" y="3155000"/>
+            <a:off x="8650000" y="3425000"/>
             <a:ext cx="1190000" cy="180000"/>
           </a:xfrm>
           <a:prstGeom prst="rect">
@@ -5146,7 +5146,7 @@
         </p:nvSpPr>
         <p:spPr>
           <a:xfrm>
-            <a:off x="8670000" y="3370000"/>
+            <a:off x="8670000" y="3640000"/>
             <a:ext cx="1150000" cy="280000"/>
           </a:xfrm>
           <a:prstGeom prst="rect">
@@ -5180,7 +5180,7 @@
         </p:nvSpPr>
         <p:spPr>
           <a:xfrm>
-            <a:off x="9950000" y="3270000"/>
+            <a:off x="9950000" y="3540000"/>
             <a:ext cx="250000" cy="250000"/>
           </a:xfrm>
           <a:prstGeom prst="rect">
@@ -5214,7 +5214,7 @@
         </p:nvSpPr>
         <p:spPr>
           <a:xfrm>
-            <a:off x="10140000" y="3020000"/>
+            <a:off x="10140000" y="3290000"/>
             <a:ext cx="1350000" cy="760000"/>
           </a:xfrm>
           <a:prstGeom prst="roundRect">
@@ -5243,7 +5243,7 @@
         </p:nvSpPr>
         <p:spPr>
           <a:xfrm>
-            <a:off x="10220000" y="3155000"/>
+            <a:off x="10220000" y="3425000"/>
             <a:ext cx="1190000" cy="180000"/>
           </a:xfrm>
           <a:prstGeom prst="rect">
@@ -5277,7 +5277,7 @@
         </p:nvSpPr>
         <p:spPr>
           <a:xfrm>
-            <a:off x="10240000" y="3370000"/>
+            <a:off x="10240000" y="3640000"/>
             <a:ext cx="1150000" cy="280000"/>
           </a:xfrm>
           <a:prstGeom prst="rect">
@@ -5311,7 +5311,7 @@
         </p:nvSpPr>
         <p:spPr>
           <a:xfrm>
-            <a:off x="11520000" y="3270000"/>
+            <a:off x="11520000" y="3540000"/>
             <a:ext cx="250000" cy="250000"/>
           </a:xfrm>
           <a:prstGeom prst="rect">
@@ -5345,7 +5345,7 @@
         </p:nvSpPr>
         <p:spPr>
           <a:xfrm>
-            <a:off x="11710000" y="3020000"/>
+            <a:off x="11710000" y="3290000"/>
             <a:ext cx="1350000" cy="760000"/>
           </a:xfrm>
           <a:prstGeom prst="roundRect">
@@ -5374,7 +5374,7 @@
         </p:nvSpPr>
         <p:spPr>
           <a:xfrm>
-            <a:off x="11790000" y="3155000"/>
+            <a:off x="11790000" y="3425000"/>
             <a:ext cx="1190000" cy="180000"/>
           </a:xfrm>
           <a:prstGeom prst="rect">
@@ -5408,7 +5408,7 @@
         </p:nvSpPr>
         <p:spPr>
           <a:xfrm>
-            <a:off x="11810000" y="3370000"/>
+            <a:off x="11810000" y="3640000"/>
             <a:ext cx="1150000" cy="280000"/>
           </a:xfrm>
           <a:prstGeom prst="rect">
@@ -5589,21 +5589,21 @@
         </p:nvSpPr>
         <p:spPr>
           <a:xfrm>
-            <a:off x="620000" y="775000"/>
-            <a:ext cx="7700000" cy="980000"/>
-          </a:xfrm>
-          <a:prstGeom prst="rect">
-            <a:avLst/>
-          </a:prstGeom>
-          <a:noFill/>
-        </p:spPr>
-        <p:txBody>
-          <a:bodyPr wrap="square" anchor="t"/>
-          <a:lstStyle/>
-          <a:p>
-            <a:pPr algn="l"/>
-            <a:r>
-              <a:rPr lang="es-BO" sz="4050" dirty="0">
+            <a:off x="620000" y="760000"/>
+            <a:ext cx="8250000" cy="1260000"/>
+          </a:xfrm>
+          <a:prstGeom prst="rect">
+            <a:avLst/>
+          </a:prstGeom>
+          <a:noFill/>
+        </p:spPr>
+        <p:txBody>
+          <a:bodyPr wrap="square" anchor="t"/>
+          <a:lstStyle/>
+          <a:p>
+            <a:pPr algn="l"/>
+            <a:r>
+              <a:rPr lang="es-BO" sz="3450" dirty="0">
                 <a:b/>
                 <a:solidFill>
                   <a:srgbClr val="12372A"/>
@@ -5623,21 +5623,21 @@
         </p:nvSpPr>
         <p:spPr>
           <a:xfrm>
-            <a:off x="630000" y="1710000"/>
-            <a:ext cx="7850000" cy="570000"/>
-          </a:xfrm>
-          <a:prstGeom prst="rect">
-            <a:avLst/>
-          </a:prstGeom>
-          <a:noFill/>
-        </p:spPr>
-        <p:txBody>
-          <a:bodyPr wrap="square" anchor="t"/>
-          <a:lstStyle/>
-          <a:p>
-            <a:pPr algn="l"/>
-            <a:r>
-              <a:rPr lang="es-BO" sz="1950" dirty="0">
+            <a:off x="630000" y="2140000"/>
+            <a:ext cx="8350000" cy="620000"/>
+          </a:xfrm>
+          <a:prstGeom prst="rect">
+            <a:avLst/>
+          </a:prstGeom>
+          <a:noFill/>
+        </p:spPr>
+        <p:txBody>
+          <a:bodyPr wrap="square" anchor="t"/>
+          <a:lstStyle/>
+          <a:p>
+            <a:pPr algn="l"/>
+            <a:r>
+              <a:rPr lang="es-BO" sz="1850" dirty="0">
                 <a:solidFill>
                   <a:srgbClr val="56635C"/>
                 </a:solidFill>
@@ -5656,7 +5656,7 @@
         </p:nvSpPr>
         <p:spPr>
           <a:xfrm>
-            <a:off x="770000" y="2702000"/>
+            <a:off x="770000" y="3082000"/>
             <a:ext cx="95000" cy="95000"/>
           </a:xfrm>
           <a:prstGeom prst="ellipse">
@@ -5683,7 +5683,7 @@
         </p:nvSpPr>
         <p:spPr>
           <a:xfrm>
-            <a:off x="925000" y="2650000"/>
+            <a:off x="925000" y="3030000"/>
             <a:ext cx="6695000" cy="260000"/>
           </a:xfrm>
           <a:prstGeom prst="rect">
@@ -5716,7 +5716,7 @@
         </p:nvSpPr>
         <p:spPr>
           <a:xfrm>
-            <a:off x="770000" y="3087000"/>
+            <a:off x="770000" y="3467000"/>
             <a:ext cx="95000" cy="95000"/>
           </a:xfrm>
           <a:prstGeom prst="ellipse">
@@ -5743,7 +5743,7 @@
         </p:nvSpPr>
         <p:spPr>
           <a:xfrm>
-            <a:off x="925000" y="3035000"/>
+            <a:off x="925000" y="3415000"/>
             <a:ext cx="6695000" cy="260000"/>
           </a:xfrm>
           <a:prstGeom prst="rect">
@@ -5776,7 +5776,7 @@
         </p:nvSpPr>
         <p:spPr>
           <a:xfrm>
-            <a:off x="770000" y="3472000"/>
+            <a:off x="770000" y="3852000"/>
             <a:ext cx="95000" cy="95000"/>
           </a:xfrm>
           <a:prstGeom prst="ellipse">
@@ -5803,7 +5803,7 @@
         </p:nvSpPr>
         <p:spPr>
           <a:xfrm>
-            <a:off x="925000" y="3420000"/>
+            <a:off x="925000" y="3800000"/>
             <a:ext cx="6695000" cy="260000"/>
           </a:xfrm>
           <a:prstGeom prst="rect">
@@ -5836,7 +5836,7 @@
         </p:nvSpPr>
         <p:spPr>
           <a:xfrm>
-            <a:off x="770000" y="3857000"/>
+            <a:off x="770000" y="4237000"/>
             <a:ext cx="95000" cy="95000"/>
           </a:xfrm>
           <a:prstGeom prst="ellipse">
@@ -5863,7 +5863,7 @@
         </p:nvSpPr>
         <p:spPr>
           <a:xfrm>
-            <a:off x="925000" y="3805000"/>
+            <a:off x="925000" y="4185000"/>
             <a:ext cx="6695000" cy="260000"/>
           </a:xfrm>
           <a:prstGeom prst="rect">
@@ -5896,7 +5896,7 @@
         </p:nvSpPr>
         <p:spPr>
           <a:xfrm>
-            <a:off x="770000" y="4242000"/>
+            <a:off x="770000" y="4622000"/>
             <a:ext cx="95000" cy="95000"/>
           </a:xfrm>
           <a:prstGeom prst="ellipse">
@@ -5923,7 +5923,7 @@
         </p:nvSpPr>
         <p:spPr>
           <a:xfrm>
-            <a:off x="925000" y="4190000"/>
+            <a:off x="925000" y="4570000"/>
             <a:ext cx="6695000" cy="260000"/>
           </a:xfrm>
           <a:prstGeom prst="rect">
@@ -5956,7 +5956,7 @@
         </p:nvSpPr>
         <p:spPr>
           <a:xfrm>
-            <a:off x="8250000" y="2600000"/>
+            <a:off x="8250000" y="3030000"/>
             <a:ext cx="3950000" cy="2650000"/>
           </a:xfrm>
           <a:prstGeom prst="roundRect">
@@ -5985,7 +5985,7 @@
         </p:nvSpPr>
         <p:spPr>
           <a:xfrm>
-            <a:off x="8600000" y="3470000"/>
+            <a:off x="8600000" y="3900000"/>
             <a:ext cx="3250000" cy="620000"/>
           </a:xfrm>
           <a:prstGeom prst="rect">
@@ -6166,21 +6166,21 @@
         </p:nvSpPr>
         <p:spPr>
           <a:xfrm>
-            <a:off x="620000" y="775000"/>
-            <a:ext cx="7700000" cy="980000"/>
-          </a:xfrm>
-          <a:prstGeom prst="rect">
-            <a:avLst/>
-          </a:prstGeom>
-          <a:noFill/>
-        </p:spPr>
-        <p:txBody>
-          <a:bodyPr wrap="square" anchor="t"/>
-          <a:lstStyle/>
-          <a:p>
-            <a:pPr algn="l"/>
-            <a:r>
-              <a:rPr lang="es-BO" sz="4050" dirty="0">
+            <a:off x="620000" y="760000"/>
+            <a:ext cx="8250000" cy="1260000"/>
+          </a:xfrm>
+          <a:prstGeom prst="rect">
+            <a:avLst/>
+          </a:prstGeom>
+          <a:noFill/>
+        </p:spPr>
+        <p:txBody>
+          <a:bodyPr wrap="square" anchor="t"/>
+          <a:lstStyle/>
+          <a:p>
+            <a:pPr algn="l"/>
+            <a:r>
+              <a:rPr lang="es-BO" sz="3450" dirty="0">
                 <a:b/>
                 <a:solidFill>
                   <a:srgbClr val="12372A"/>
@@ -6200,21 +6200,21 @@
         </p:nvSpPr>
         <p:spPr>
           <a:xfrm>
-            <a:off x="630000" y="1710000"/>
-            <a:ext cx="7850000" cy="570000"/>
-          </a:xfrm>
-          <a:prstGeom prst="rect">
-            <a:avLst/>
-          </a:prstGeom>
-          <a:noFill/>
-        </p:spPr>
-        <p:txBody>
-          <a:bodyPr wrap="square" anchor="t"/>
-          <a:lstStyle/>
-          <a:p>
-            <a:pPr algn="l"/>
-            <a:r>
-              <a:rPr lang="es-BO" sz="1950" dirty="0">
+            <a:off x="630000" y="2140000"/>
+            <a:ext cx="8350000" cy="620000"/>
+          </a:xfrm>
+          <a:prstGeom prst="rect">
+            <a:avLst/>
+          </a:prstGeom>
+          <a:noFill/>
+        </p:spPr>
+        <p:txBody>
+          <a:bodyPr wrap="square" anchor="t"/>
+          <a:lstStyle/>
+          <a:p>
+            <a:pPr algn="l"/>
+            <a:r>
+              <a:rPr lang="es-BO" sz="1850" dirty="0">
                 <a:solidFill>
                   <a:srgbClr val="56635C"/>
                 </a:solidFill>
@@ -6233,8 +6233,8 @@
         </p:nvSpPr>
         <p:spPr>
           <a:xfrm>
-            <a:off x="820000" y="2680000"/>
-            <a:ext cx="4950000" cy="3520000"/>
+            <a:off x="820000" y="3030000"/>
+            <a:ext cx="4950000" cy="3220000"/>
           </a:xfrm>
           <a:prstGeom prst="roundRect">
             <a:avLst/>
@@ -6262,21 +6262,21 @@
         </p:nvSpPr>
         <p:spPr>
           <a:xfrm>
-            <a:off x="1080000" y="2930000"/>
-            <a:ext cx="4430000" cy="360000"/>
-          </a:xfrm>
-          <a:prstGeom prst="rect">
-            <a:avLst/>
-          </a:prstGeom>
-          <a:noFill/>
-        </p:spPr>
-        <p:txBody>
-          <a:bodyPr wrap="square" anchor="t"/>
-          <a:lstStyle/>
-          <a:p>
-            <a:pPr algn="l"/>
-            <a:r>
-              <a:rPr lang="es-BO" sz="2300" dirty="0">
+            <a:off x="1080000" y="3260000"/>
+            <a:ext cx="4430000" cy="340000"/>
+          </a:xfrm>
+          <a:prstGeom prst="rect">
+            <a:avLst/>
+          </a:prstGeom>
+          <a:noFill/>
+        </p:spPr>
+        <p:txBody>
+          <a:bodyPr wrap="square" anchor="t"/>
+          <a:lstStyle/>
+          <a:p>
+            <a:pPr algn="l"/>
+            <a:r>
+              <a:rPr lang="es-BO" sz="2200" dirty="0">
                 <a:b/>
                 <a:solidFill>
                   <a:srgbClr val="1B7F5C"/>
@@ -6296,7 +6296,7 @@
         </p:nvSpPr>
         <p:spPr>
           <a:xfrm>
-            <a:off x="1120000" y="3512000"/>
+            <a:off x="1120000" y="3802000"/>
             <a:ext cx="95000" cy="95000"/>
           </a:xfrm>
           <a:prstGeom prst="ellipse">
@@ -6323,7 +6323,7 @@
         </p:nvSpPr>
         <p:spPr>
           <a:xfrm>
-            <a:off x="1275000" y="3460000"/>
+            <a:off x="1275000" y="3750000"/>
             <a:ext cx="4215000" cy="260000"/>
           </a:xfrm>
           <a:prstGeom prst="rect">
@@ -6356,7 +6356,7 @@
         </p:nvSpPr>
         <p:spPr>
           <a:xfrm>
-            <a:off x="1120000" y="3897000"/>
+            <a:off x="1120000" y="4187000"/>
             <a:ext cx="95000" cy="95000"/>
           </a:xfrm>
           <a:prstGeom prst="ellipse">
@@ -6383,7 +6383,7 @@
         </p:nvSpPr>
         <p:spPr>
           <a:xfrm>
-            <a:off x="1275000" y="3845000"/>
+            <a:off x="1275000" y="4135000"/>
             <a:ext cx="4215000" cy="260000"/>
           </a:xfrm>
           <a:prstGeom prst="rect">
@@ -6416,7 +6416,7 @@
         </p:nvSpPr>
         <p:spPr>
           <a:xfrm>
-            <a:off x="1120000" y="4282000"/>
+            <a:off x="1120000" y="4572000"/>
             <a:ext cx="95000" cy="95000"/>
           </a:xfrm>
           <a:prstGeom prst="ellipse">
@@ -6443,7 +6443,7 @@
         </p:nvSpPr>
         <p:spPr>
           <a:xfrm>
-            <a:off x="1275000" y="4230000"/>
+            <a:off x="1275000" y="4520000"/>
             <a:ext cx="4215000" cy="260000"/>
           </a:xfrm>
           <a:prstGeom prst="rect">
@@ -6476,7 +6476,7 @@
         </p:nvSpPr>
         <p:spPr>
           <a:xfrm>
-            <a:off x="1120000" y="4667000"/>
+            <a:off x="1120000" y="4957000"/>
             <a:ext cx="95000" cy="95000"/>
           </a:xfrm>
           <a:prstGeom prst="ellipse">
@@ -6503,7 +6503,7 @@
         </p:nvSpPr>
         <p:spPr>
           <a:xfrm>
-            <a:off x="1275000" y="4615000"/>
+            <a:off x="1275000" y="4905000"/>
             <a:ext cx="4215000" cy="260000"/>
           </a:xfrm>
           <a:prstGeom prst="rect">
@@ -6536,7 +6536,7 @@
         </p:nvSpPr>
         <p:spPr>
           <a:xfrm>
-            <a:off x="1120000" y="5052000"/>
+            <a:off x="1120000" y="5342000"/>
             <a:ext cx="95000" cy="95000"/>
           </a:xfrm>
           <a:prstGeom prst="ellipse">
@@ -6563,7 +6563,7 @@
         </p:nvSpPr>
         <p:spPr>
           <a:xfrm>
-            <a:off x="1275000" y="5000000"/>
+            <a:off x="1275000" y="5290000"/>
             <a:ext cx="4215000" cy="260000"/>
           </a:xfrm>
           <a:prstGeom prst="rect">
@@ -6596,7 +6596,7 @@
         </p:nvSpPr>
         <p:spPr>
           <a:xfrm>
-            <a:off x="1120000" y="5437000"/>
+            <a:off x="1120000" y="5727000"/>
             <a:ext cx="95000" cy="95000"/>
           </a:xfrm>
           <a:prstGeom prst="ellipse">
@@ -6623,7 +6623,7 @@
         </p:nvSpPr>
         <p:spPr>
           <a:xfrm>
-            <a:off x="1275000" y="5385000"/>
+            <a:off x="1275000" y="5675000"/>
             <a:ext cx="4215000" cy="260000"/>
           </a:xfrm>
           <a:prstGeom prst="rect">
@@ -6656,8 +6656,8 @@
         </p:nvSpPr>
         <p:spPr>
           <a:xfrm>
-            <a:off x="6110000" y="2680000"/>
-            <a:ext cx="4950000" cy="3520000"/>
+            <a:off x="6110000" y="3030000"/>
+            <a:ext cx="4950000" cy="3220000"/>
           </a:xfrm>
           <a:prstGeom prst="roundRect">
             <a:avLst/>
@@ -6685,21 +6685,21 @@
         </p:nvSpPr>
         <p:spPr>
           <a:xfrm>
-            <a:off x="6370000" y="2930000"/>
-            <a:ext cx="4430000" cy="360000"/>
-          </a:xfrm>
-          <a:prstGeom prst="rect">
-            <a:avLst/>
-          </a:prstGeom>
-          <a:noFill/>
-        </p:spPr>
-        <p:txBody>
-          <a:bodyPr wrap="square" anchor="t"/>
-          <a:lstStyle/>
-          <a:p>
-            <a:pPr algn="l"/>
-            <a:r>
-              <a:rPr lang="es-BO" sz="2300" dirty="0">
+            <a:off x="6370000" y="3260000"/>
+            <a:ext cx="4430000" cy="340000"/>
+          </a:xfrm>
+          <a:prstGeom prst="rect">
+            <a:avLst/>
+          </a:prstGeom>
+          <a:noFill/>
+        </p:spPr>
+        <p:txBody>
+          <a:bodyPr wrap="square" anchor="t"/>
+          <a:lstStyle/>
+          <a:p>
+            <a:pPr algn="l"/>
+            <a:r>
+              <a:rPr lang="es-BO" sz="2200" dirty="0">
                 <a:b/>
                 <a:solidFill>
                   <a:srgbClr val="1B7F5C"/>
@@ -6719,7 +6719,7 @@
         </p:nvSpPr>
         <p:spPr>
           <a:xfrm>
-            <a:off x="6410000" y="3512000"/>
+            <a:off x="6410000" y="3802000"/>
             <a:ext cx="95000" cy="95000"/>
           </a:xfrm>
           <a:prstGeom prst="ellipse">
@@ -6746,7 +6746,7 @@
         </p:nvSpPr>
         <p:spPr>
           <a:xfrm>
-            <a:off x="6565000" y="3460000"/>
+            <a:off x="6565000" y="3750000"/>
             <a:ext cx="4215000" cy="260000"/>
           </a:xfrm>
           <a:prstGeom prst="rect">
@@ -6779,7 +6779,7 @@
         </p:nvSpPr>
         <p:spPr>
           <a:xfrm>
-            <a:off x="6410000" y="3897000"/>
+            <a:off x="6410000" y="4187000"/>
             <a:ext cx="95000" cy="95000"/>
           </a:xfrm>
           <a:prstGeom prst="ellipse">
@@ -6806,7 +6806,7 @@
         </p:nvSpPr>
         <p:spPr>
           <a:xfrm>
-            <a:off x="6565000" y="3845000"/>
+            <a:off x="6565000" y="4135000"/>
             <a:ext cx="4215000" cy="260000"/>
           </a:xfrm>
           <a:prstGeom prst="rect">
@@ -6839,7 +6839,7 @@
         </p:nvSpPr>
         <p:spPr>
           <a:xfrm>
-            <a:off x="6410000" y="4282000"/>
+            <a:off x="6410000" y="4572000"/>
             <a:ext cx="95000" cy="95000"/>
           </a:xfrm>
           <a:prstGeom prst="ellipse">
@@ -6866,7 +6866,7 @@
         </p:nvSpPr>
         <p:spPr>
           <a:xfrm>
-            <a:off x="6565000" y="4230000"/>
+            <a:off x="6565000" y="4520000"/>
             <a:ext cx="4215000" cy="260000"/>
           </a:xfrm>
           <a:prstGeom prst="rect">
@@ -6899,7 +6899,7 @@
         </p:nvSpPr>
         <p:spPr>
           <a:xfrm>
-            <a:off x="6410000" y="4667000"/>
+            <a:off x="6410000" y="4957000"/>
             <a:ext cx="95000" cy="95000"/>
           </a:xfrm>
           <a:prstGeom prst="ellipse">
@@ -6926,7 +6926,7 @@
         </p:nvSpPr>
         <p:spPr>
           <a:xfrm>
-            <a:off x="6565000" y="4615000"/>
+            <a:off x="6565000" y="4905000"/>
             <a:ext cx="4215000" cy="260000"/>
           </a:xfrm>
           <a:prstGeom prst="rect">
@@ -6959,7 +6959,7 @@
         </p:nvSpPr>
         <p:spPr>
           <a:xfrm>
-            <a:off x="6410000" y="5052000"/>
+            <a:off x="6410000" y="5342000"/>
             <a:ext cx="95000" cy="95000"/>
           </a:xfrm>
           <a:prstGeom prst="ellipse">
@@ -6986,7 +6986,7 @@
         </p:nvSpPr>
         <p:spPr>
           <a:xfrm>
-            <a:off x="6565000" y="5000000"/>
+            <a:off x="6565000" y="5290000"/>
             <a:ext cx="4215000" cy="260000"/>
           </a:xfrm>
           <a:prstGeom prst="rect">
@@ -7019,7 +7019,7 @@
         </p:nvSpPr>
         <p:spPr>
           <a:xfrm>
-            <a:off x="8500000" y="4920000"/>
+            <a:off x="8500000" y="5140000"/>
             <a:ext cx="3900000" cy="1150000"/>
           </a:xfrm>
           <a:prstGeom prst="roundRect">
@@ -7046,7 +7046,7 @@
         </p:nvSpPr>
         <p:spPr>
           <a:xfrm>
-            <a:off x="8790000" y="5180000"/>
+            <a:off x="8790000" y="5400000"/>
             <a:ext cx="3320000" cy="540000"/>
           </a:xfrm>
           <a:prstGeom prst="rect">
@@ -7060,7 +7060,7 @@
           <a:p>
             <a:pPr algn="c"/>
             <a:r>
-              <a:rPr lang="es-BO" sz="2050" dirty="0">
+              <a:rPr lang="es-BO" sz="1950" dirty="0">
                 <a:b/>
                 <a:solidFill>
                   <a:srgbClr val="FFFFFF"/>
@@ -7227,21 +7227,21 @@
         </p:nvSpPr>
         <p:spPr>
           <a:xfrm>
-            <a:off x="620000" y="775000"/>
-            <a:ext cx="7700000" cy="980000"/>
-          </a:xfrm>
-          <a:prstGeom prst="rect">
-            <a:avLst/>
-          </a:prstGeom>
-          <a:noFill/>
-        </p:spPr>
-        <p:txBody>
-          <a:bodyPr wrap="square" anchor="t"/>
-          <a:lstStyle/>
-          <a:p>
-            <a:pPr algn="l"/>
-            <a:r>
-              <a:rPr lang="es-BO" sz="4050" dirty="0">
+            <a:off x="620000" y="760000"/>
+            <a:ext cx="8250000" cy="1260000"/>
+          </a:xfrm>
+          <a:prstGeom prst="rect">
+            <a:avLst/>
+          </a:prstGeom>
+          <a:noFill/>
+        </p:spPr>
+        <p:txBody>
+          <a:bodyPr wrap="square" anchor="t"/>
+          <a:lstStyle/>
+          <a:p>
+            <a:pPr algn="l"/>
+            <a:r>
+              <a:rPr lang="es-BO" sz="3450" dirty="0">
                 <a:b/>
                 <a:solidFill>
                   <a:srgbClr val="12372A"/>
@@ -7261,21 +7261,21 @@
         </p:nvSpPr>
         <p:spPr>
           <a:xfrm>
-            <a:off x="630000" y="1710000"/>
-            <a:ext cx="7850000" cy="570000"/>
-          </a:xfrm>
-          <a:prstGeom prst="rect">
-            <a:avLst/>
-          </a:prstGeom>
-          <a:noFill/>
-        </p:spPr>
-        <p:txBody>
-          <a:bodyPr wrap="square" anchor="t"/>
-          <a:lstStyle/>
-          <a:p>
-            <a:pPr algn="l"/>
-            <a:r>
-              <a:rPr lang="es-BO" sz="1950" dirty="0">
+            <a:off x="630000" y="2140000"/>
+            <a:ext cx="8350000" cy="620000"/>
+          </a:xfrm>
+          <a:prstGeom prst="rect">
+            <a:avLst/>
+          </a:prstGeom>
+          <a:noFill/>
+        </p:spPr>
+        <p:txBody>
+          <a:bodyPr wrap="square" anchor="t"/>
+          <a:lstStyle/>
+          <a:p>
+            <a:pPr algn="l"/>
+            <a:r>
+              <a:rPr lang="es-BO" sz="1850" dirty="0">
                 <a:solidFill>
                   <a:srgbClr val="56635C"/>
                 </a:solidFill>
@@ -7294,7 +7294,7 @@
         </p:nvSpPr>
         <p:spPr>
           <a:xfrm>
-            <a:off x="770000" y="2702000"/>
+            <a:off x="770000" y="3082000"/>
             <a:ext cx="95000" cy="95000"/>
           </a:xfrm>
           <a:prstGeom prst="ellipse">
@@ -7321,7 +7321,7 @@
         </p:nvSpPr>
         <p:spPr>
           <a:xfrm>
-            <a:off x="925000" y="2650000"/>
+            <a:off x="925000" y="3030000"/>
             <a:ext cx="6695000" cy="260000"/>
           </a:xfrm>
           <a:prstGeom prst="rect">
@@ -7354,7 +7354,7 @@
         </p:nvSpPr>
         <p:spPr>
           <a:xfrm>
-            <a:off x="770000" y="3087000"/>
+            <a:off x="770000" y="3467000"/>
             <a:ext cx="95000" cy="95000"/>
           </a:xfrm>
           <a:prstGeom prst="ellipse">
@@ -7381,7 +7381,7 @@
         </p:nvSpPr>
         <p:spPr>
           <a:xfrm>
-            <a:off x="925000" y="3035000"/>
+            <a:off x="925000" y="3415000"/>
             <a:ext cx="6695000" cy="260000"/>
           </a:xfrm>
           <a:prstGeom prst="rect">
@@ -7414,7 +7414,7 @@
         </p:nvSpPr>
         <p:spPr>
           <a:xfrm>
-            <a:off x="770000" y="3472000"/>
+            <a:off x="770000" y="3852000"/>
             <a:ext cx="95000" cy="95000"/>
           </a:xfrm>
           <a:prstGeom prst="ellipse">
@@ -7441,7 +7441,7 @@
         </p:nvSpPr>
         <p:spPr>
           <a:xfrm>
-            <a:off x="925000" y="3420000"/>
+            <a:off x="925000" y="3800000"/>
             <a:ext cx="6695000" cy="260000"/>
           </a:xfrm>
           <a:prstGeom prst="rect">
@@ -7474,7 +7474,7 @@
         </p:nvSpPr>
         <p:spPr>
           <a:xfrm>
-            <a:off x="770000" y="3857000"/>
+            <a:off x="770000" y="4237000"/>
             <a:ext cx="95000" cy="95000"/>
           </a:xfrm>
           <a:prstGeom prst="ellipse">
@@ -7501,7 +7501,7 @@
         </p:nvSpPr>
         <p:spPr>
           <a:xfrm>
-            <a:off x="925000" y="3805000"/>
+            <a:off x="925000" y="4185000"/>
             <a:ext cx="6695000" cy="260000"/>
           </a:xfrm>
           <a:prstGeom prst="rect">
@@ -7534,7 +7534,7 @@
         </p:nvSpPr>
         <p:spPr>
           <a:xfrm>
-            <a:off x="770000" y="4242000"/>
+            <a:off x="770000" y="4622000"/>
             <a:ext cx="95000" cy="95000"/>
           </a:xfrm>
           <a:prstGeom prst="ellipse">
@@ -7561,7 +7561,7 @@
         </p:nvSpPr>
         <p:spPr>
           <a:xfrm>
-            <a:off x="925000" y="4190000"/>
+            <a:off x="925000" y="4570000"/>
             <a:ext cx="6695000" cy="260000"/>
           </a:xfrm>
           <a:prstGeom prst="rect">
@@ -7594,7 +7594,7 @@
         </p:nvSpPr>
         <p:spPr>
           <a:xfrm>
-            <a:off x="770000" y="4627000"/>
+            <a:off x="770000" y="5007000"/>
             <a:ext cx="95000" cy="95000"/>
           </a:xfrm>
           <a:prstGeom prst="ellipse">
@@ -7621,7 +7621,7 @@
         </p:nvSpPr>
         <p:spPr>
           <a:xfrm>
-            <a:off x="925000" y="4575000"/>
+            <a:off x="925000" y="4955000"/>
             <a:ext cx="6695000" cy="260000"/>
           </a:xfrm>
           <a:prstGeom prst="rect">
@@ -7801,21 +7801,21 @@
         </p:nvSpPr>
         <p:spPr>
           <a:xfrm>
-            <a:off x="620000" y="775000"/>
-            <a:ext cx="7700000" cy="980000"/>
-          </a:xfrm>
-          <a:prstGeom prst="rect">
-            <a:avLst/>
-          </a:prstGeom>
-          <a:noFill/>
-        </p:spPr>
-        <p:txBody>
-          <a:bodyPr wrap="square" anchor="t"/>
-          <a:lstStyle/>
-          <a:p>
-            <a:pPr algn="l"/>
-            <a:r>
-              <a:rPr lang="es-BO" sz="4050" dirty="0">
+            <a:off x="620000" y="760000"/>
+            <a:ext cx="8250000" cy="1260000"/>
+          </a:xfrm>
+          <a:prstGeom prst="rect">
+            <a:avLst/>
+          </a:prstGeom>
+          <a:noFill/>
+        </p:spPr>
+        <p:txBody>
+          <a:bodyPr wrap="square" anchor="t"/>
+          <a:lstStyle/>
+          <a:p>
+            <a:pPr algn="l"/>
+            <a:r>
+              <a:rPr lang="es-BO" sz="3450" dirty="0">
                 <a:b/>
                 <a:solidFill>
                   <a:srgbClr val="12372A"/>
@@ -7835,21 +7835,21 @@
         </p:nvSpPr>
         <p:spPr>
           <a:xfrm>
-            <a:off x="630000" y="1710000"/>
-            <a:ext cx="7850000" cy="570000"/>
-          </a:xfrm>
-          <a:prstGeom prst="rect">
-            <a:avLst/>
-          </a:prstGeom>
-          <a:noFill/>
-        </p:spPr>
-        <p:txBody>
-          <a:bodyPr wrap="square" anchor="t"/>
-          <a:lstStyle/>
-          <a:p>
-            <a:pPr algn="l"/>
-            <a:r>
-              <a:rPr lang="es-BO" sz="1950" dirty="0">
+            <a:off x="630000" y="2140000"/>
+            <a:ext cx="8350000" cy="620000"/>
+          </a:xfrm>
+          <a:prstGeom prst="rect">
+            <a:avLst/>
+          </a:prstGeom>
+          <a:noFill/>
+        </p:spPr>
+        <p:txBody>
+          <a:bodyPr wrap="square" anchor="t"/>
+          <a:lstStyle/>
+          <a:p>
+            <a:pPr algn="l"/>
+            <a:r>
+              <a:rPr lang="es-BO" sz="1850" dirty="0">
                 <a:solidFill>
                   <a:srgbClr val="56635C"/>
                 </a:solidFill>
@@ -7868,14 +7868,14 @@
         </p:nvSpPr>
         <p:spPr>
           <a:xfrm>
-            <a:off x="830000" y="2620000"/>
+            <a:off x="830000" y="3030000"/>
             <a:ext cx="7350000" cy="340000"/>
           </a:xfrm>
           <a:prstGeom prst="rect">
             <a:avLst/>
           </a:prstGeom>
           <a:solidFill>
-            <a:srgbClr val="FFFFFF"/>
+            <a:srgbClr val="DDF6E8"/>
           </a:solidFill>
           <a:ln>
             <a:noFill/>
@@ -7895,7 +7895,7 @@
         </p:nvSpPr>
         <p:spPr>
           <a:xfrm>
-            <a:off x="1050000" y="2690000"/>
+            <a:off x="1050000" y="3100000"/>
             <a:ext cx="4900000" cy="170000"/>
           </a:xfrm>
           <a:prstGeom prst="rect">
@@ -7928,7 +7928,7 @@
         </p:nvSpPr>
         <p:spPr>
           <a:xfrm>
-            <a:off x="6000000" y="2690000"/>
+            <a:off x="6000000" y="3100000"/>
             <a:ext cx="1900000" cy="170000"/>
           </a:xfrm>
           <a:prstGeom prst="rect">
@@ -7962,14 +7962,14 @@
         </p:nvSpPr>
         <p:spPr>
           <a:xfrm>
-            <a:off x="830000" y="3065000"/>
+            <a:off x="830000" y="3475000"/>
             <a:ext cx="7350000" cy="340000"/>
           </a:xfrm>
           <a:prstGeom prst="rect">
             <a:avLst/>
           </a:prstGeom>
           <a:solidFill>
-            <a:srgbClr val="DDF6E8"/>
+            <a:srgbClr val="FFFFFF"/>
           </a:solidFill>
           <a:ln>
             <a:noFill/>
@@ -7989,7 +7989,7 @@
         </p:nvSpPr>
         <p:spPr>
           <a:xfrm>
-            <a:off x="1050000" y="3135000"/>
+            <a:off x="1050000" y="3545000"/>
             <a:ext cx="4900000" cy="170000"/>
           </a:xfrm>
           <a:prstGeom prst="rect">
@@ -8022,7 +8022,7 @@
         </p:nvSpPr>
         <p:spPr>
           <a:xfrm>
-            <a:off x="6000000" y="3135000"/>
+            <a:off x="6000000" y="3545000"/>
             <a:ext cx="1900000" cy="170000"/>
           </a:xfrm>
           <a:prstGeom prst="rect">
@@ -8056,14 +8056,14 @@
         </p:nvSpPr>
         <p:spPr>
           <a:xfrm>
-            <a:off x="830000" y="3510000"/>
+            <a:off x="830000" y="3920000"/>
             <a:ext cx="7350000" cy="340000"/>
           </a:xfrm>
           <a:prstGeom prst="rect">
             <a:avLst/>
           </a:prstGeom>
           <a:solidFill>
-            <a:srgbClr val="FFFFFF"/>
+            <a:srgbClr val="DDF6E8"/>
           </a:solidFill>
           <a:ln>
             <a:noFill/>
@@ -8083,7 +8083,7 @@
         </p:nvSpPr>
         <p:spPr>
           <a:xfrm>
-            <a:off x="1050000" y="3580000"/>
+            <a:off x="1050000" y="3990000"/>
             <a:ext cx="4900000" cy="170000"/>
           </a:xfrm>
           <a:prstGeom prst="rect">
@@ -8116,7 +8116,7 @@
         </p:nvSpPr>
         <p:spPr>
           <a:xfrm>
-            <a:off x="6000000" y="3580000"/>
+            <a:off x="6000000" y="3990000"/>
             <a:ext cx="1900000" cy="170000"/>
           </a:xfrm>
           <a:prstGeom prst="rect">
@@ -8150,14 +8150,14 @@
         </p:nvSpPr>
         <p:spPr>
           <a:xfrm>
-            <a:off x="830000" y="3955000"/>
+            <a:off x="830000" y="4365000"/>
             <a:ext cx="7350000" cy="340000"/>
           </a:xfrm>
           <a:prstGeom prst="rect">
             <a:avLst/>
           </a:prstGeom>
           <a:solidFill>
-            <a:srgbClr val="DDF6E8"/>
+            <a:srgbClr val="FFFFFF"/>
           </a:solidFill>
           <a:ln>
             <a:noFill/>
@@ -8177,7 +8177,7 @@
         </p:nvSpPr>
         <p:spPr>
           <a:xfrm>
-            <a:off x="1050000" y="4025000"/>
+            <a:off x="1050000" y="4435000"/>
             <a:ext cx="4900000" cy="170000"/>
           </a:xfrm>
           <a:prstGeom prst="rect">
@@ -8210,7 +8210,7 @@
         </p:nvSpPr>
         <p:spPr>
           <a:xfrm>
-            <a:off x="6000000" y="4025000"/>
+            <a:off x="6000000" y="4435000"/>
             <a:ext cx="1900000" cy="170000"/>
           </a:xfrm>
           <a:prstGeom prst="rect">
@@ -8244,7 +8244,7 @@
         </p:nvSpPr>
         <p:spPr>
           <a:xfrm>
-            <a:off x="830000" y="4400000"/>
+            <a:off x="830000" y="4810000"/>
             <a:ext cx="7350000" cy="340000"/>
           </a:xfrm>
           <a:prstGeom prst="rect">
@@ -8271,7 +8271,7 @@
         </p:nvSpPr>
         <p:spPr>
           <a:xfrm>
-            <a:off x="1050000" y="4470000"/>
+            <a:off x="1050000" y="4880000"/>
             <a:ext cx="4900000" cy="170000"/>
           </a:xfrm>
           <a:prstGeom prst="rect">
@@ -8304,7 +8304,7 @@
         </p:nvSpPr>
         <p:spPr>
           <a:xfrm>
-            <a:off x="6000000" y="4470000"/>
+            <a:off x="6000000" y="4880000"/>
             <a:ext cx="1900000" cy="170000"/>
           </a:xfrm>
           <a:prstGeom prst="rect">
@@ -8338,7 +8338,7 @@
         </p:nvSpPr>
         <p:spPr>
           <a:xfrm>
-            <a:off x="830000" y="4845000"/>
+            <a:off x="830000" y="5255000"/>
             <a:ext cx="7350000" cy="340000"/>
           </a:xfrm>
           <a:prstGeom prst="rect">
@@ -8365,7 +8365,7 @@
         </p:nvSpPr>
         <p:spPr>
           <a:xfrm>
-            <a:off x="1050000" y="4915000"/>
+            <a:off x="1050000" y="5325000"/>
             <a:ext cx="4900000" cy="170000"/>
           </a:xfrm>
           <a:prstGeom prst="rect">
@@ -8398,7 +8398,7 @@
         </p:nvSpPr>
         <p:spPr>
           <a:xfrm>
-            <a:off x="6000000" y="4915000"/>
+            <a:off x="6000000" y="5325000"/>
             <a:ext cx="1900000" cy="170000"/>
           </a:xfrm>
           <a:prstGeom prst="rect">
@@ -8432,7 +8432,7 @@
         </p:nvSpPr>
         <p:spPr>
           <a:xfrm>
-            <a:off x="830000" y="5290000"/>
+            <a:off x="830000" y="5700000"/>
             <a:ext cx="7350000" cy="340000"/>
           </a:xfrm>
           <a:prstGeom prst="rect">
@@ -8459,7 +8459,7 @@
         </p:nvSpPr>
         <p:spPr>
           <a:xfrm>
-            <a:off x="1050000" y="5360000"/>
+            <a:off x="1050000" y="5770000"/>
             <a:ext cx="4900000" cy="170000"/>
           </a:xfrm>
           <a:prstGeom prst="rect">
@@ -8492,7 +8492,7 @@
         </p:nvSpPr>
         <p:spPr>
           <a:xfrm>
-            <a:off x="6000000" y="5360000"/>
+            <a:off x="6000000" y="5770000"/>
             <a:ext cx="1900000" cy="170000"/>
           </a:xfrm>
           <a:prstGeom prst="rect">

</xml_diff>